<commit_message>
Refactor FIRDSM techniques and parameters; update plots and presentation
- Updated FIRDSM_techniques_onoff.m to enhance clarity and adjust metastability time constant.
- Refined FIRDSM_thermal_decimation.m for improved voltage scaling and thermal noise analysis.
- Modified build_pptx.py to adjust text sizes and alignments, and added a references slide.
- Adjusted firdsm_coeffs.m and firdsm_params.m for better coefficient handling and parameter definitions.
- Enhanced firdsm_run.m to streamline quantization and integration processes.
- Updated mbq.m for improved mid-rise multi-bit quantization.
- Updated various result images to reflect changes in simulations and analyses.
</commit_message>
<xml_diff>
--- a/practical-exam/Final_oral_exam_Daniel_Tyukov_5714699.pptx
+++ b/practical-exam/Final_oral_exam_Daniel_Tyukov_5714699.pptx
@@ -6294,7 +6294,7 @@
           <a:lstStyle/>
           <a:p>
             <a:r>
-              <a:rPr sz="2800">
+              <a:rPr sz="2000">
                 <a:solidFill>
                   <a:srgbClr val="FFFFFF"/>
                 </a:solidFill>
@@ -6327,7 +6327,7 @@
           <a:p>
             <a:pPr/>
             <a:r>
-              <a:rPr sz="1800" b="0">
+              <a:rPr sz="1600" b="0">
                 <a:solidFill>
                   <a:srgbClr val="00A6D6"/>
                 </a:solidFill>
@@ -6338,7 +6338,7 @@
           <a:p>
             <a:pPr/>
             <a:r>
-              <a:rPr sz="1800" b="1">
+              <a:rPr sz="1600" b="1">
                 <a:solidFill>
                   <a:srgbClr val="00A6D6"/>
                 </a:solidFill>
@@ -7860,7 +7860,7 @@
                   <a:srgbClr val="000000"/>
                 </a:solidFill>
               </a:rPr>
-              <a:t>I4 (the input integrator) dominates because it processes the largest signal.</a:t>
+              <a:t>The input integrator is the dominant one: its non-linearity acts on the unfiltered input/feedback.</a:t>
             </a:r>
           </a:p>
           <a:p>
@@ -7871,7 +7871,7 @@
                   <a:srgbClr val="000000"/>
                 </a:solidFill>
               </a:rPr>
-              <a:t>Modelled as a per-sub-step cubic term; impact: out-of-band shaped noise demodulates in-band -&gt; floor rises.</a:t>
+              <a:t>Modelled as a cubic on the I4 input; impact: it folds out-of-band shaped noise in-band -&gt; floor rises.</a:t>
             </a:r>
           </a:p>
           <a:p>
@@ -7882,7 +7882,7 @@
                   <a:srgbClr val="000000"/>
                 </a:solidFill>
               </a:rPr>
-              <a:t>Conclusion: FIR feedback relaxes the I4 linearity demand; the cubic raises the in-band floor like the 4-bit case.</a:t>
+              <a:t>Conclusion: the input integrator sets the linearity budget; G3 raises the in-band floor (SNDR 94 -&gt; 76 dB at G3=0.1).</a:t>
             </a:r>
           </a:p>
         </p:txBody>
@@ -10846,9 +10846,111 @@
           </a:p>
         </p:txBody>
       </p:sp>
+      <p:sp>
+        <p:nvSpPr>
+          <p:cNvPr id="18" name="TextBox 17"/>
+          <p:cNvSpPr txBox="1"/>
+          <p:nvPr/>
+        </p:nvSpPr>
+        <p:spPr>
+          <a:xfrm>
+            <a:off x="274320" y="3383280"/>
+            <a:ext cx="4023360" cy="274320"/>
+          </a:xfrm>
+          <a:prstGeom prst="rect">
+            <a:avLst/>
+          </a:prstGeom>
+          <a:noFill/>
+        </p:spPr>
+        <p:txBody>
+          <a:bodyPr wrap="square" anchor="t">
+            <a:spAutoFit/>
+          </a:bodyPr>
+          <a:lstStyle/>
+          <a:p>
+            <a:pPr/>
+            <a:r>
+              <a:rPr sz="1100" b="1">
+                <a:solidFill>
+                  <a:srgbClr val="000000"/>
+                </a:solidFill>
+              </a:rPr>
+              <a:t>PSD: HD2 down ~15 dB (Fig 30)</a:t>
+            </a:r>
+          </a:p>
+        </p:txBody>
+      </p:sp>
+      <p:sp>
+        <p:nvSpPr>
+          <p:cNvPr id="19" name="TextBox 18"/>
+          <p:cNvSpPr txBox="1"/>
+          <p:nvPr/>
+        </p:nvSpPr>
+        <p:spPr>
+          <a:xfrm>
+            <a:off x="4434840" y="3383280"/>
+            <a:ext cx="4023360" cy="274320"/>
+          </a:xfrm>
+          <a:prstGeom prst="rect">
+            <a:avLst/>
+          </a:prstGeom>
+          <a:noFill/>
+        </p:spPr>
+        <p:txBody>
+          <a:bodyPr wrap="square" anchor="t">
+            <a:spAutoFit/>
+          </a:bodyPr>
+          <a:lstStyle/>
+          <a:p>
+            <a:pPr/>
+            <a:r>
+              <a:rPr sz="1100" b="1">
+                <a:solidFill>
+                  <a:srgbClr val="000000"/>
+                </a:solidFill>
+              </a:rPr>
+              <a:t>SNDR vs amplitude: kink removed (Fig 29)</a:t>
+            </a:r>
+          </a:p>
+        </p:txBody>
+      </p:sp>
+      <p:sp>
+        <p:nvSpPr>
+          <p:cNvPr id="20" name="TextBox 19"/>
+          <p:cNvSpPr txBox="1"/>
+          <p:nvPr/>
+        </p:nvSpPr>
+        <p:spPr>
+          <a:xfrm>
+            <a:off x="8595360" y="3383280"/>
+            <a:ext cx="3931920" cy="274320"/>
+          </a:xfrm>
+          <a:prstGeom prst="rect">
+            <a:avLst/>
+          </a:prstGeom>
+          <a:noFill/>
+        </p:spPr>
+        <p:txBody>
+          <a:bodyPr wrap="square" anchor="t">
+            <a:spAutoFit/>
+          </a:bodyPr>
+          <a:lstStyle/>
+          <a:p>
+            <a:pPr/>
+            <a:r>
+              <a:rPr sz="1100" b="1">
+                <a:solidFill>
+                  <a:srgbClr val="000000"/>
+                </a:solidFill>
+              </a:rPr>
+              <a:t>paper Fig 30</a:t>
+            </a:r>
+          </a:p>
+        </p:txBody>
+      </p:sp>
       <p:pic>
         <p:nvPicPr>
-          <p:cNvPr id="18" name="Picture 17" descr="FIRDSM_isi_correction.png"/>
+          <p:cNvPr id="21" name="Picture 20" descr="FIRDSM_isi_correction.png"/>
           <p:cNvPicPr>
             <a:picLocks noChangeAspect="1"/>
           </p:cNvPicPr>
@@ -10862,8 +10964,8 @@
         </p:blipFill>
         <p:spPr>
           <a:xfrm>
-            <a:off x="411480" y="3577873"/>
-            <a:ext cx="6126480" cy="3999933"/>
+            <a:off x="274320" y="4401589"/>
+            <a:ext cx="4023360" cy="2626821"/>
           </a:xfrm>
           <a:prstGeom prst="rect">
             <a:avLst/>
@@ -10872,7 +10974,7 @@
       </p:pic>
       <p:pic>
         <p:nvPicPr>
-          <p:cNvPr id="19" name="Picture 18" descr="fig30_psd_with_without_isi_correction.png"/>
+          <p:cNvPr id="22" name="Picture 21" descr="FIRDSM_isi_sndr_vs_amp.png"/>
           <p:cNvPicPr>
             <a:picLocks noChangeAspect="1"/>
           </p:cNvPicPr>
@@ -10886,17 +10988,41 @@
         </p:blipFill>
         <p:spPr>
           <a:xfrm>
-            <a:off x="7011424" y="3474720"/>
-            <a:ext cx="5362432" cy="4206240"/>
+            <a:off x="4434840" y="4373880"/>
+            <a:ext cx="4023360" cy="2682240"/>
           </a:xfrm>
           <a:prstGeom prst="rect">
             <a:avLst/>
           </a:prstGeom>
         </p:spPr>
       </p:pic>
+      <p:pic>
+        <p:nvPicPr>
+          <p:cNvPr id="23" name="Picture 22" descr="fig30_psd_with_without_isi_correction.png"/>
+          <p:cNvPicPr>
+            <a:picLocks noChangeAspect="1"/>
+          </p:cNvPicPr>
+          <p:nvPr/>
+        </p:nvPicPr>
+        <p:blipFill>
+          <a:blip r:embed="rId4"/>
+          <a:stretch>
+            <a:fillRect/>
+          </a:stretch>
+        </p:blipFill>
+        <p:spPr>
+          <a:xfrm>
+            <a:off x="8595360" y="4172920"/>
+            <a:ext cx="3931920" cy="3084159"/>
+          </a:xfrm>
+          <a:prstGeom prst="rect">
+            <a:avLst/>
+          </a:prstGeom>
+        </p:spPr>
+      </p:pic>
       <p:sp>
         <p:nvSpPr>
-          <p:cNvPr id="20" name="TextBox 19"/>
+          <p:cNvPr id="24" name="TextBox 23"/>
           <p:cNvSpPr txBox="1"/>
           <p:nvPr/>
         </p:nvSpPr>
@@ -11127,7 +11253,7 @@
         <p:spPr>
           <a:xfrm>
             <a:off x="411480" y="1554480"/>
-            <a:ext cx="6126480" cy="7863840"/>
+            <a:ext cx="5120640" cy="7863840"/>
           </a:xfrm>
         </p:spPr>
         <p:txBody>
@@ -11345,7 +11471,7 @@
         </p:blipFill>
         <p:spPr>
           <a:xfrm>
-            <a:off x="8927262" y="1554480"/>
+            <a:off x="8287182" y="1554480"/>
             <a:ext cx="1530755" cy="3200400"/>
           </a:xfrm>
           <a:prstGeom prst="rect">
@@ -11369,8 +11495,8 @@
         </p:blipFill>
         <p:spPr>
           <a:xfrm>
-            <a:off x="6675120" y="5758109"/>
-            <a:ext cx="6035039" cy="2199782"/>
+            <a:off x="5486400" y="5466689"/>
+            <a:ext cx="7132320" cy="2599742"/>
           </a:xfrm>
           <a:prstGeom prst="rect">
             <a:avLst/>
@@ -12883,7 +13009,7 @@
                   <a:srgbClr val="000000"/>
                 </a:solidFill>
               </a:rPr>
-              <a:t>Your result - MATLAB</a:t>
+              <a:t>My result - MATLAB</a:t>
             </a:r>
           </a:p>
         </p:txBody>
@@ -12960,7 +13086,7 @@
                   <a:srgbClr val="000000"/>
                 </a:solidFill>
               </a:rPr>
-              <a:t>Conclusion: STF peaks ~+12 dB and needs an input pre-filter; matches Fig 9.</a:t>
+              <a:t>Conclusion: Same bandpass shape as Fig 9: ~+12 dB peak then rolls off (peak ~200 MHz vs ~100 MHz); needs input pre-filter.</a:t>
             </a:r>
           </a:p>
         </p:txBody>
@@ -13313,7 +13439,7 @@
                   <a:srgbClr val="000000"/>
                 </a:solidFill>
               </a:rPr>
-              <a:t>Your result - MATLAB</a:t>
+              <a:t>My result - MATLAB</a:t>
             </a:r>
           </a:p>
         </p:txBody>
@@ -13743,7 +13869,7 @@
                   <a:srgbClr val="000000"/>
                 </a:solidFill>
               </a:rPr>
-              <a:t>Your result - MATLAB</a:t>
+              <a:t>My result - MATLAB</a:t>
             </a:r>
           </a:p>
         </p:txBody>
@@ -14173,7 +14299,7 @@
                   <a:srgbClr val="000000"/>
                 </a:solidFill>
               </a:rPr>
-              <a:t>Your result - MATLAB</a:t>
+              <a:t>My result - MATLAB</a:t>
             </a:r>
           </a:p>
         </p:txBody>
@@ -14603,7 +14729,7 @@
                   <a:srgbClr val="000000"/>
                 </a:solidFill>
               </a:rPr>
-              <a:t>Your result - MATLAB</a:t>
+              <a:t>My result - MATLAB</a:t>
             </a:r>
           </a:p>
         </p:txBody>
@@ -15033,7 +15159,7 @@
                   <a:srgbClr val="000000"/>
                 </a:solidFill>
               </a:rPr>
-              <a:t>Your result - MATLAB</a:t>
+              <a:t>My result - MATLAB</a:t>
             </a:r>
           </a:p>
         </p:txBody>
@@ -15303,7 +15429,7 @@
                   <a:srgbClr val="000000"/>
                 </a:solidFill>
               </a:rPr>
-              <a:t>Input feed-forward kff = 2.5 (STF peaking); H1(s) bandpass, peak ~100 MHz</a:t>
+              <a:t>Input feed-forward kff = 1.2 into last integrator (STF peaking); H1(s) bandpass ~100 MHz</a:t>
             </a:r>
           </a:p>
           <a:p>
@@ -15804,7 +15930,7 @@
                   <a:srgbClr val="000000"/>
                 </a:solidFill>
               </a:rPr>
-              <a:t>Your result - MATLAB</a:t>
+              <a:t>My result - MATLAB</a:t>
             </a:r>
           </a:p>
         </p:txBody>
@@ -16234,7 +16360,7 @@
                   <a:srgbClr val="000000"/>
                 </a:solidFill>
               </a:rPr>
-              <a:t>Your result - MATLAB</a:t>
+              <a:t>My result - MATLAB</a:t>
             </a:r>
           </a:p>
         </p:txBody>
@@ -17494,7 +17620,7 @@
         <p:spPr>
           <a:xfrm>
             <a:off x="411480" y="1554480"/>
-            <a:ext cx="5852160" cy="6400800"/>
+            <a:ext cx="5120640" cy="6400800"/>
           </a:xfrm>
         </p:spPr>
         <p:txBody>
@@ -17650,8 +17776,32 @@
         </p:blipFill>
         <p:spPr>
           <a:xfrm>
-            <a:off x="6492240" y="2725063"/>
-            <a:ext cx="6217920" cy="4059633"/>
+            <a:off x="6275793" y="1463040"/>
+            <a:ext cx="5462093" cy="3566160"/>
+          </a:xfrm>
+          <a:prstGeom prst="rect">
+            <a:avLst/>
+          </a:prstGeom>
+        </p:spPr>
+      </p:pic>
+      <p:pic>
+        <p:nvPicPr>
+          <p:cNvPr id="19" name="Picture 18" descr="FIRDSM_transient.png"/>
+          <p:cNvPicPr>
+            <a:picLocks noChangeAspect="1"/>
+          </p:cNvPicPr>
+          <p:nvPr/>
+        </p:nvPicPr>
+        <p:blipFill>
+          <a:blip r:embed="rId3"/>
+          <a:stretch>
+            <a:fillRect/>
+          </a:stretch>
+        </p:blipFill>
+        <p:spPr>
+          <a:xfrm>
+            <a:off x="6588690" y="5029200"/>
+            <a:ext cx="4836299" cy="3566160"/>
           </a:xfrm>
           <a:prstGeom prst="rect">
             <a:avLst/>
@@ -19051,7 +19201,7 @@
                   <a:srgbClr val="000000"/>
                 </a:solidFill>
               </a:rPr>
-              <a:t>Your result - MATLAB</a:t>
+              <a:t>My result - MATLAB</a:t>
             </a:r>
           </a:p>
         </p:txBody>
@@ -19128,7 +19278,7 @@
                   <a:srgbClr val="000000"/>
                 </a:solidFill>
               </a:rPr>
-              <a:t>Conclusion: 4th-order, OBG = 1.5, two in-band notches; matches Fig 8.</a:t>
+              <a:t>Conclusion: Same 4th-order high-pass shape as Fig 8: OBG = 1.5 plateau, two in-band notches (~-100 dB).</a:t>
             </a:r>
           </a:p>
         </p:txBody>

</xml_diff>

<commit_message>
Update practical exam materials and results images
</commit_message>
<xml_diff>
--- a/practical-exam/Final_oral_exam_Daniel_Tyukov_5714699.pptx
+++ b/practical-exam/Final_oral_exam_Daniel_Tyukov_5714699.pptx
@@ -42,6 +42,7 @@
     <p:sldId id="498" r:id="rId18"/>
     <p:sldId id="500" r:id="rId19"/>
     <p:sldId id="488" r:id="rId20"/>
+    <p:sldId id="513" r:id="rId40"/>
   </p:sldIdLst>
   <p:sldSz cx="13004800" cy="9753600"/>
   <p:notesSz cx="7315200" cy="9601200"/>
@@ -6325,7 +6326,7 @@
           <a:bodyPr wrap="square"/>
           <a:lstStyle/>
           <a:p>
-            <a:pPr/>
+            <a:pPr algn="l"/>
             <a:r>
               <a:rPr sz="1600" b="0">
                 <a:solidFill>
@@ -6336,7 +6337,7 @@
             </a:r>
           </a:p>
           <a:p>
-            <a:pPr/>
+            <a:pPr algn="l"/>
             <a:r>
               <a:rPr sz="1600" b="1">
                 <a:solidFill>
@@ -6599,7 +6600,7 @@
             </a:r>
           </a:p>
           <a:p>
-            <a:pPr/>
+            <a:pPr algn="l"/>
             <a:r>
               <a:rPr sz="1200" b="0">
                 <a:solidFill>
@@ -6610,7 +6611,7 @@
             </a:r>
           </a:p>
           <a:p>
-            <a:pPr/>
+            <a:pPr algn="l"/>
             <a:r>
               <a:rPr sz="1200" b="0">
                 <a:solidFill>
@@ -6621,7 +6622,7 @@
             </a:r>
           </a:p>
           <a:p>
-            <a:pPr/>
+            <a:pPr algn="l"/>
             <a:r>
               <a:rPr sz="1200" b="1">
                 <a:solidFill>
@@ -6925,7 +6926,7 @@
             </a:r>
           </a:p>
           <a:p>
-            <a:pPr/>
+            <a:pPr algn="l"/>
             <a:r>
               <a:rPr sz="1200" b="0">
                 <a:solidFill>
@@ -6936,7 +6937,7 @@
             </a:r>
           </a:p>
           <a:p>
-            <a:pPr/>
+            <a:pPr algn="l"/>
             <a:r>
               <a:rPr sz="1200" b="0">
                 <a:solidFill>
@@ -6947,7 +6948,7 @@
             </a:r>
           </a:p>
           <a:p>
-            <a:pPr/>
+            <a:pPr algn="l"/>
             <a:r>
               <a:rPr sz="1200" b="1">
                 <a:solidFill>
@@ -7234,7 +7235,7 @@
             </a:r>
           </a:p>
           <a:p>
-            <a:pPr/>
+            <a:pPr algn="l"/>
             <a:r>
               <a:rPr sz="1200" b="0">
                 <a:solidFill>
@@ -7245,7 +7246,7 @@
             </a:r>
           </a:p>
           <a:p>
-            <a:pPr/>
+            <a:pPr algn="l"/>
             <a:r>
               <a:rPr sz="1200" b="0">
                 <a:solidFill>
@@ -7256,7 +7257,7 @@
             </a:r>
           </a:p>
           <a:p>
-            <a:pPr/>
+            <a:pPr algn="l"/>
             <a:r>
               <a:rPr sz="1200" b="1">
                 <a:solidFill>
@@ -7543,7 +7544,7 @@
             </a:r>
           </a:p>
           <a:p>
-            <a:pPr/>
+            <a:pPr algn="l"/>
             <a:r>
               <a:rPr sz="1200" b="0">
                 <a:solidFill>
@@ -7554,7 +7555,7 @@
             </a:r>
           </a:p>
           <a:p>
-            <a:pPr/>
+            <a:pPr algn="l"/>
             <a:r>
               <a:rPr sz="1200" b="0">
                 <a:solidFill>
@@ -7565,7 +7566,7 @@
             </a:r>
           </a:p>
           <a:p>
-            <a:pPr/>
+            <a:pPr algn="l"/>
             <a:r>
               <a:rPr sz="1200" b="1">
                 <a:solidFill>
@@ -7853,7 +7854,7 @@
             </a:r>
           </a:p>
           <a:p>
-            <a:pPr/>
+            <a:pPr algn="l"/>
             <a:r>
               <a:rPr sz="1200" b="0">
                 <a:solidFill>
@@ -7864,7 +7865,7 @@
             </a:r>
           </a:p>
           <a:p>
-            <a:pPr/>
+            <a:pPr algn="l"/>
             <a:r>
               <a:rPr sz="1200" b="0">
                 <a:solidFill>
@@ -7875,7 +7876,7 @@
             </a:r>
           </a:p>
           <a:p>
-            <a:pPr/>
+            <a:pPr algn="l"/>
             <a:r>
               <a:rPr sz="1200" b="1">
                 <a:solidFill>
@@ -8150,7 +8151,7 @@
             </a:r>
           </a:p>
           <a:p>
-            <a:pPr/>
+            <a:pPr algn="l"/>
             <a:r>
               <a:rPr sz="1200" b="0">
                 <a:solidFill>
@@ -8161,7 +8162,7 @@
             </a:r>
           </a:p>
           <a:p>
-            <a:pPr/>
+            <a:pPr algn="l"/>
             <a:r>
               <a:rPr sz="1200" b="0">
                 <a:solidFill>
@@ -8172,7 +8173,7 @@
             </a:r>
           </a:p>
           <a:p>
-            <a:pPr/>
+            <a:pPr algn="l"/>
             <a:r>
               <a:rPr sz="1200" b="1">
                 <a:solidFill>
@@ -9047,7 +9048,7 @@
           </a:bodyPr>
           <a:lstStyle/>
           <a:p>
-            <a:pPr/>
+            <a:pPr algn="l"/>
             <a:r>
               <a:rPr sz="1200" b="1">
                 <a:solidFill>
@@ -10598,7 +10599,7 @@
           </a:bodyPr>
           <a:lstStyle/>
           <a:p>
-            <a:pPr/>
+            <a:pPr algn="l"/>
             <a:r>
               <a:rPr sz="1400" b="1">
                 <a:solidFill>
@@ -10609,7 +10610,7 @@
             </a:r>
           </a:p>
           <a:p>
-            <a:pPr lvl="1"/>
+            <a:pPr lvl="1" algn="l"/>
             <a:r>
               <a:rPr sz="1200" b="0">
                 <a:solidFill>
@@ -10620,7 +10621,7 @@
             </a:r>
           </a:p>
           <a:p>
-            <a:pPr lvl="1"/>
+            <a:pPr lvl="1" algn="l"/>
             <a:r>
               <a:rPr sz="1200" b="0">
                 <a:solidFill>
@@ -10631,7 +10632,7 @@
             </a:r>
           </a:p>
           <a:p>
-            <a:pPr/>
+            <a:pPr algn="l"/>
             <a:r>
               <a:rPr sz="1100" b="1">
                 <a:solidFill>
@@ -10730,7 +10731,7 @@
           </a:bodyPr>
           <a:lstStyle/>
           <a:p>
-            <a:pPr/>
+            <a:pPr algn="l"/>
             <a:r>
               <a:rPr sz="1600" b="1">
                 <a:solidFill>
@@ -10741,7 +10742,7 @@
             </a:r>
           </a:p>
           <a:p>
-            <a:pPr lvl="1"/>
+            <a:pPr lvl="1" algn="l"/>
             <a:r>
               <a:rPr sz="1300" b="0">
                 <a:solidFill>
@@ -10752,7 +10753,7 @@
             </a:r>
           </a:p>
           <a:p>
-            <a:pPr lvl="1"/>
+            <a:pPr lvl="1" algn="l"/>
             <a:r>
               <a:rPr sz="1300" b="0">
                 <a:solidFill>
@@ -10763,7 +10764,7 @@
             </a:r>
           </a:p>
           <a:p>
-            <a:pPr lvl="1"/>
+            <a:pPr lvl="1" algn="l"/>
             <a:r>
               <a:rPr sz="1300" b="0">
                 <a:solidFill>
@@ -10774,7 +10775,7 @@
             </a:r>
           </a:p>
           <a:p>
-            <a:pPr lvl="1"/>
+            <a:pPr lvl="1" algn="l"/>
             <a:r>
               <a:rPr sz="1300" b="0">
                 <a:solidFill>
@@ -10868,7 +10869,7 @@
           </a:bodyPr>
           <a:lstStyle/>
           <a:p>
-            <a:pPr/>
+            <a:pPr algn="l"/>
             <a:r>
               <a:rPr sz="1100" b="1">
                 <a:solidFill>
@@ -10902,7 +10903,7 @@
           </a:bodyPr>
           <a:lstStyle/>
           <a:p>
-            <a:pPr/>
+            <a:pPr algn="l"/>
             <a:r>
               <a:rPr sz="1100" b="1">
                 <a:solidFill>
@@ -10936,7 +10937,7 @@
           </a:bodyPr>
           <a:lstStyle/>
           <a:p>
-            <a:pPr/>
+            <a:pPr algn="l"/>
             <a:r>
               <a:rPr sz="1100" b="1">
                 <a:solidFill>
@@ -11042,7 +11043,7 @@
           </a:bodyPr>
           <a:lstStyle/>
           <a:p>
-            <a:pPr/>
+            <a:pPr algn="l"/>
             <a:r>
               <a:rPr sz="1300" b="1">
                 <a:solidFill>
@@ -11132,7 +11133,7 @@
           <a:bodyPr wrap="square"/>
           <a:lstStyle/>
           <a:p>
-            <a:pPr/>
+            <a:pPr algn="l"/>
             <a:r>
               <a:rPr sz="1600" b="1">
                 <a:solidFill>
@@ -11143,7 +11144,7 @@
             </a:r>
           </a:p>
           <a:p>
-            <a:pPr/>
+            <a:pPr algn="l"/>
             <a:r>
               <a:rPr sz="1500" b="0">
                 <a:solidFill>
@@ -11154,7 +11155,7 @@
             </a:r>
           </a:p>
           <a:p>
-            <a:pPr/>
+            <a:pPr algn="l"/>
             <a:r>
               <a:rPr sz="1500" b="0">
                 <a:solidFill>
@@ -11165,7 +11166,7 @@
             </a:r>
           </a:p>
           <a:p>
-            <a:pPr/>
+            <a:pPr algn="l"/>
             <a:r>
               <a:rPr sz="1400" b="1">
                 <a:solidFill>
@@ -11260,7 +11261,7 @@
           <a:bodyPr wrap="square"/>
           <a:lstStyle/>
           <a:p>
-            <a:pPr/>
+            <a:pPr algn="l"/>
             <a:r>
               <a:rPr sz="1600" b="1">
                 <a:solidFill>
@@ -11271,7 +11272,7 @@
             </a:r>
           </a:p>
           <a:p>
-            <a:pPr lvl="1"/>
+            <a:pPr lvl="1" algn="l"/>
             <a:r>
               <a:rPr sz="1300" b="0">
                 <a:solidFill>
@@ -11282,7 +11283,7 @@
             </a:r>
           </a:p>
           <a:p>
-            <a:pPr lvl="1"/>
+            <a:pPr lvl="1" algn="l"/>
             <a:r>
               <a:rPr sz="1300" b="0">
                 <a:solidFill>
@@ -11293,7 +11294,7 @@
             </a:r>
           </a:p>
           <a:p>
-            <a:pPr lvl="1"/>
+            <a:pPr lvl="1" algn="l"/>
             <a:r>
               <a:rPr sz="1300" b="0">
                 <a:solidFill>
@@ -11304,7 +11305,7 @@
             </a:r>
           </a:p>
           <a:p>
-            <a:pPr lvl="1"/>
+            <a:pPr lvl="1" algn="l"/>
             <a:r>
               <a:rPr sz="1300" b="0">
                 <a:solidFill>
@@ -11315,7 +11316,7 @@
             </a:r>
           </a:p>
           <a:p>
-            <a:pPr lvl="1"/>
+            <a:pPr lvl="1" algn="l"/>
             <a:r>
               <a:rPr sz="1300" b="0">
                 <a:solidFill>
@@ -11326,7 +11327,7 @@
             </a:r>
           </a:p>
           <a:p>
-            <a:pPr/>
+            <a:pPr algn="l"/>
             <a:r>
               <a:rPr sz="1500" b="1">
                 <a:solidFill>
@@ -11337,7 +11338,7 @@
             </a:r>
           </a:p>
           <a:p>
-            <a:pPr lvl="1"/>
+            <a:pPr lvl="1" algn="l"/>
             <a:r>
               <a:rPr sz="1300" b="0">
                 <a:solidFill>
@@ -11348,7 +11349,7 @@
             </a:r>
           </a:p>
           <a:p>
-            <a:pPr lvl="1"/>
+            <a:pPr lvl="1" algn="l"/>
             <a:r>
               <a:rPr sz="1300" b="0">
                 <a:solidFill>
@@ -11359,7 +11360,7 @@
             </a:r>
           </a:p>
           <a:p>
-            <a:pPr lvl="1"/>
+            <a:pPr lvl="1" algn="l"/>
             <a:r>
               <a:rPr sz="1300" b="0">
                 <a:solidFill>
@@ -11370,7 +11371,7 @@
             </a:r>
           </a:p>
           <a:p>
-            <a:pPr lvl="1"/>
+            <a:pPr lvl="1" algn="l"/>
             <a:r>
               <a:rPr sz="1300" b="0">
                 <a:solidFill>
@@ -11381,7 +11382,7 @@
             </a:r>
           </a:p>
           <a:p>
-            <a:pPr lvl="1"/>
+            <a:pPr lvl="1" algn="l"/>
             <a:r>
               <a:rPr sz="1300" b="0">
                 <a:solidFill>
@@ -11392,7 +11393,7 @@
             </a:r>
           </a:p>
           <a:p>
-            <a:pPr/>
+            <a:pPr algn="l"/>
             <a:r>
               <a:rPr sz="1300" b="1">
                 <a:solidFill>
@@ -11735,7 +11736,7 @@
             </a:r>
           </a:p>
           <a:p>
-            <a:pPr/>
+            <a:pPr algn="l"/>
             <a:r>
               <a:rPr sz="1200" b="0">
                 <a:solidFill>
@@ -11746,7 +11747,7 @@
             </a:r>
           </a:p>
           <a:p>
-            <a:pPr/>
+            <a:pPr algn="l"/>
             <a:r>
               <a:rPr sz="1200" b="0">
                 <a:solidFill>
@@ -11757,7 +11758,7 @@
             </a:r>
           </a:p>
           <a:p>
-            <a:pPr/>
+            <a:pPr algn="l"/>
             <a:r>
               <a:rPr sz="1200" b="1">
                 <a:solidFill>
@@ -12044,7 +12045,7 @@
             </a:r>
           </a:p>
           <a:p>
-            <a:pPr/>
+            <a:pPr algn="l"/>
             <a:r>
               <a:rPr sz="1200" b="0">
                 <a:solidFill>
@@ -12055,7 +12056,7 @@
             </a:r>
           </a:p>
           <a:p>
-            <a:pPr/>
+            <a:pPr algn="l"/>
             <a:r>
               <a:rPr sz="1200" b="0">
                 <a:solidFill>
@@ -12066,7 +12067,7 @@
             </a:r>
           </a:p>
           <a:p>
-            <a:pPr/>
+            <a:pPr algn="l"/>
             <a:r>
               <a:rPr sz="1200" b="1">
                 <a:solidFill>
@@ -12329,7 +12330,7 @@
             </a:r>
           </a:p>
           <a:p>
-            <a:pPr/>
+            <a:pPr algn="l"/>
             <a:r>
               <a:rPr sz="1200" b="0">
                 <a:solidFill>
@@ -12340,7 +12341,7 @@
             </a:r>
           </a:p>
           <a:p>
-            <a:pPr/>
+            <a:pPr algn="l"/>
             <a:r>
               <a:rPr sz="1200" b="0">
                 <a:solidFill>
@@ -12351,7 +12352,7 @@
             </a:r>
           </a:p>
           <a:p>
-            <a:pPr/>
+            <a:pPr algn="l"/>
             <a:r>
               <a:rPr sz="1200" b="1">
                 <a:solidFill>
@@ -12662,7 +12663,7 @@
             </a:r>
           </a:p>
           <a:p>
-            <a:pPr/>
+            <a:pPr algn="l"/>
             <a:r>
               <a:rPr sz="1200" b="0">
                 <a:solidFill>
@@ -12673,7 +12674,7 @@
             </a:r>
           </a:p>
           <a:p>
-            <a:pPr/>
+            <a:pPr algn="l"/>
             <a:r>
               <a:rPr sz="1200" b="1">
                 <a:solidFill>
@@ -12784,7 +12785,7 @@
           </a:bodyPr>
           <a:lstStyle/>
           <a:p>
-            <a:pPr/>
+            <a:pPr algn="l"/>
             <a:r>
               <a:rPr sz="1300" b="0">
                 <a:solidFill>
@@ -13214,7 +13215,7 @@
           </a:bodyPr>
           <a:lstStyle/>
           <a:p>
-            <a:pPr/>
+            <a:pPr algn="l"/>
             <a:r>
               <a:rPr sz="1300" b="0">
                 <a:solidFill>
@@ -13644,7 +13645,7 @@
           </a:bodyPr>
           <a:lstStyle/>
           <a:p>
-            <a:pPr/>
+            <a:pPr algn="l"/>
             <a:r>
               <a:rPr sz="1300" b="0">
                 <a:solidFill>
@@ -14074,7 +14075,7 @@
           </a:bodyPr>
           <a:lstStyle/>
           <a:p>
-            <a:pPr/>
+            <a:pPr algn="l"/>
             <a:r>
               <a:rPr sz="1300" b="0">
                 <a:solidFill>
@@ -14504,7 +14505,7 @@
           </a:bodyPr>
           <a:lstStyle/>
           <a:p>
-            <a:pPr/>
+            <a:pPr algn="l"/>
             <a:r>
               <a:rPr sz="1300" b="0">
                 <a:solidFill>
@@ -14934,7 +14935,7 @@
           </a:bodyPr>
           <a:lstStyle/>
           <a:p>
-            <a:pPr/>
+            <a:pPr algn="l"/>
             <a:r>
               <a:rPr sz="1300" b="0">
                 <a:solidFill>
@@ -15367,7 +15368,7 @@
           <a:bodyPr wrap="square"/>
           <a:lstStyle/>
           <a:p>
-            <a:pPr/>
+            <a:pPr algn="l"/>
             <a:r>
               <a:rPr sz="1600" b="1">
                 <a:solidFill>
@@ -15378,7 +15379,7 @@
             </a:r>
           </a:p>
           <a:p>
-            <a:pPr lvl="1"/>
+            <a:pPr lvl="1" algn="l"/>
             <a:r>
               <a:rPr sz="1300" b="0">
                 <a:solidFill>
@@ -15389,7 +15390,7 @@
             </a:r>
           </a:p>
           <a:p>
-            <a:pPr lvl="1"/>
+            <a:pPr lvl="1" algn="l"/>
             <a:r>
               <a:rPr sz="1300" b="0">
                 <a:solidFill>
@@ -15400,7 +15401,7 @@
             </a:r>
           </a:p>
           <a:p>
-            <a:pPr lvl="1"/>
+            <a:pPr lvl="1" algn="l"/>
             <a:r>
               <a:rPr sz="1300" b="0">
                 <a:solidFill>
@@ -15411,7 +15412,7 @@
             </a:r>
           </a:p>
           <a:p>
-            <a:pPr lvl="1"/>
+            <a:pPr lvl="1" algn="l"/>
             <a:r>
               <a:rPr sz="1300" b="0">
                 <a:solidFill>
@@ -15422,7 +15423,7 @@
             </a:r>
           </a:p>
           <a:p>
-            <a:pPr lvl="1"/>
+            <a:pPr lvl="1" algn="l"/>
             <a:r>
               <a:rPr sz="1300" b="0">
                 <a:solidFill>
@@ -15433,7 +15434,7 @@
             </a:r>
           </a:p>
           <a:p>
-            <a:pPr lvl="1"/>
+            <a:pPr lvl="1" algn="l"/>
             <a:r>
               <a:rPr sz="1300" b="0">
                 <a:solidFill>
@@ -15444,7 +15445,7 @@
             </a:r>
           </a:p>
           <a:p>
-            <a:pPr/>
+            <a:pPr algn="l"/>
             <a:r>
               <a:rPr sz="1500" b="1">
                 <a:solidFill>
@@ -15455,7 +15456,7 @@
             </a:r>
           </a:p>
           <a:p>
-            <a:pPr lvl="1"/>
+            <a:pPr lvl="1" algn="l"/>
             <a:r>
               <a:rPr sz="1300" b="0">
                 <a:solidFill>
@@ -15466,7 +15467,7 @@
             </a:r>
           </a:p>
           <a:p>
-            <a:pPr lvl="1"/>
+            <a:pPr lvl="1" algn="l"/>
             <a:r>
               <a:rPr sz="1300" b="0">
                 <a:solidFill>
@@ -15477,7 +15478,7 @@
             </a:r>
           </a:p>
           <a:p>
-            <a:pPr lvl="1"/>
+            <a:pPr lvl="1" algn="l"/>
             <a:r>
               <a:rPr sz="1300" b="0">
                 <a:solidFill>
@@ -15488,7 +15489,7 @@
             </a:r>
           </a:p>
           <a:p>
-            <a:pPr lvl="1"/>
+            <a:pPr lvl="1" algn="l"/>
             <a:r>
               <a:rPr sz="1300" b="0">
                 <a:solidFill>
@@ -15499,7 +15500,7 @@
             </a:r>
           </a:p>
           <a:p>
-            <a:pPr/>
+            <a:pPr algn="l"/>
             <a:r>
               <a:rPr sz="1200" b="1">
                 <a:solidFill>
@@ -15705,7 +15706,7 @@
           </a:bodyPr>
           <a:lstStyle/>
           <a:p>
-            <a:pPr/>
+            <a:pPr algn="l"/>
             <a:r>
               <a:rPr sz="1300" b="0">
                 <a:solidFill>
@@ -16135,7 +16136,7 @@
           </a:bodyPr>
           <a:lstStyle/>
           <a:p>
-            <a:pPr/>
+            <a:pPr algn="l"/>
             <a:r>
               <a:rPr sz="1300" b="0">
                 <a:solidFill>
@@ -16490,6 +16491,232 @@
           </a:prstGeom>
         </p:spPr>
       </p:pic>
+    </p:spTree>
+  </p:cSld>
+  <p:clrMapOvr>
+    <a:masterClrMapping/>
+  </p:clrMapOvr>
+</p:sld>
+</file>
+
+<file path=ppt/slides/slide32.xml><?xml version="1.0" encoding="utf-8"?>
+<p:sld xmlns:a="http://schemas.openxmlformats.org/drawingml/2006/main" xmlns:p="http://schemas.openxmlformats.org/presentationml/2006/main" xmlns:r="http://schemas.openxmlformats.org/officeDocument/2006/relationships">
+  <p:cSld>
+    <p:spTree>
+      <p:nvGrpSpPr>
+        <p:cNvPr id="1" name=""/>
+        <p:cNvGrpSpPr/>
+        <p:nvPr/>
+      </p:nvGrpSpPr>
+      <p:grpSpPr/>
+      <p:sp>
+        <p:nvSpPr>
+          <p:cNvPr id="4" name="Title 3">
+            <a:extLst>
+              <a:ext uri="{FF2B5EF4-FFF2-40B4-BE49-F238E27FC236}">
+                <a16:creationId xmlns:a16="http://schemas.microsoft.com/office/drawing/2014/main" id="{6B5311FD-260A-4278-A063-47A3AB718714}"/>
+              </a:ext>
+            </a:extLst>
+          </p:cNvPr>
+          <p:cNvSpPr>
+            <a:spLocks noGrp="1"/>
+          </p:cNvSpPr>
+          <p:nvPr>
+            <p:ph type="title"/>
+          </p:nvPr>
+        </p:nvSpPr>
+        <p:spPr/>
+        <p:txBody>
+          <a:bodyPr/>
+          <a:lstStyle/>
+          <a:p>
+            <a:r>
+              <a:t>References</a:t>
+            </a:r>
+          </a:p>
+        </p:txBody>
+      </p:sp>
+      <p:sp>
+        <p:nvSpPr>
+          <p:cNvPr id="5" name="Content Placeholder 4">
+            <a:extLst>
+              <a:ext uri="{FF2B5EF4-FFF2-40B4-BE49-F238E27FC236}">
+                <a16:creationId xmlns:a16="http://schemas.microsoft.com/office/drawing/2014/main" id="{217E5A14-E916-4FCB-A099-112E039F48F5}"/>
+              </a:ext>
+            </a:extLst>
+          </p:cNvPr>
+          <p:cNvSpPr>
+            <a:spLocks noGrp="1"/>
+          </p:cNvSpPr>
+          <p:nvPr>
+            <p:ph idx="1"/>
+          </p:nvPr>
+        </p:nvSpPr>
+        <p:spPr>
+          <a:xfrm>
+            <a:off x="640080" y="1463040"/>
+            <a:ext cx="11704320" cy="6949440"/>
+          </a:xfrm>
+        </p:spPr>
+        <p:txBody>
+          <a:bodyPr wrap="square"/>
+          <a:lstStyle/>
+          <a:p>
+            <a:pPr algn="l"/>
+            <a:r>
+              <a:rPr sz="1200" b="0">
+                <a:solidFill>
+                  <a:srgbClr val="000000"/>
+                </a:solidFill>
+              </a:rPr>
+              <a:t>[1] P. Shettigar and S. Pavan, "Design Techniques for Wideband Single-Bit CT Delta-Sigma Modulators With FIR Feedback DACs," IEEE JSSC, 47(12), 2012.</a:t>
+            </a:r>
+          </a:p>
+          <a:p>
+            <a:pPr algn="l"/>
+            <a:r>
+              <a:rPr sz="1200" b="0">
+                <a:solidFill>
+                  <a:srgbClr val="000000"/>
+                </a:solidFill>
+              </a:rPr>
+              <a:t>[2] J. A. Cherry and W. M. Snelgrove, "Clock jitter and quantizer metastability in CT Delta-Sigma modulators," IEEE TCAS-II, 46(6), 1999.</a:t>
+            </a:r>
+          </a:p>
+          <a:p>
+            <a:pPr algn="l"/>
+            <a:r>
+              <a:rPr sz="1200" b="0">
+                <a:solidFill>
+                  <a:srgbClr val="000000"/>
+                </a:solidFill>
+              </a:rPr>
+              <a:t>[3] D. K. Su and B. A. Wooley, "A CMOS oversampling D/A converter with a current-mode semidigital reconstruction filter," IEEE JSSC, 28(12), 1993.</a:t>
+            </a:r>
+          </a:p>
+          <a:p>
+            <a:pPr algn="l"/>
+            <a:r>
+              <a:rPr sz="1200" b="0">
+                <a:solidFill>
+                  <a:srgbClr val="000000"/>
+                </a:solidFill>
+              </a:rPr>
+              <a:t>[4] S. Pavan, "Efficient Simulation of Weak Nonlinearities in CT Oversampling Converters," IEEE TCAS-I, 57(8), 2010.</a:t>
+            </a:r>
+          </a:p>
+          <a:p>
+            <a:pPr algn="l"/>
+            <a:r>
+              <a:rPr sz="1200" b="0">
+                <a:solidFill>
+                  <a:srgbClr val="000000"/>
+                </a:solidFill>
+              </a:rPr>
+              <a:t>[5] S. Pavan and P. Sankar, "Power Reduction in CT Delta-Sigma Modulators Using the Assisted Opamp Technique," IEEE JSSC, 45(7), 2010.</a:t>
+            </a:r>
+          </a:p>
+          <a:p>
+            <a:pPr algn="l"/>
+            <a:r>
+              <a:rPr sz="1200" b="0">
+                <a:solidFill>
+                  <a:srgbClr val="000000"/>
+                </a:solidFill>
+              </a:rPr>
+              <a:t>[6] R. Adams and K. Q. Nguyen, "A 113-dB SNR oversampling DAC with segmented noise-shaped scrambling," IEEE JSSC, 33(12), 1998.</a:t>
+            </a:r>
+          </a:p>
+          <a:p>
+            <a:pPr algn="l"/>
+            <a:r>
+              <a:rPr sz="1200" b="0">
+                <a:solidFill>
+                  <a:srgbClr val="000000"/>
+                </a:solidFill>
+              </a:rPr>
+              <a:t>[7] W. L. Lee, "A novel higher order interpolative modulator topology for high resolution A/D converters," MS thesis, MIT, 1987.</a:t>
+            </a:r>
+          </a:p>
+          <a:p>
+            <a:pPr algn="l"/>
+            <a:r>
+              <a:rPr sz="1200" b="0">
+                <a:solidFill>
+                  <a:srgbClr val="000000"/>
+                </a:solidFill>
+              </a:rPr>
+              <a:t>[8] G. Mitteregger et al., "A 20-mW 640-MHz CMOS CT Delta-Sigma ADC with 20-MHz BW, 80-dB DR," IEEE JSSC, 41(12), 2006.</a:t>
+            </a:r>
+          </a:p>
+          <a:p>
+            <a:pPr algn="l"/>
+            <a:r>
+              <a:rPr sz="1200" b="0">
+                <a:solidFill>
+                  <a:srgbClr val="000000"/>
+                </a:solidFill>
+              </a:rPr>
+              <a:t>[9] M. Bolatkale et al., "A 4 GHz CT Delta-Sigma ADC with 70 dB DR and -74 dBFS THD in 125 MHz BW," IEEE JSSC, 46(12), 2011.</a:t>
+            </a:r>
+          </a:p>
+          <a:p>
+            <a:pPr algn="l"/>
+            <a:r>
+              <a:rPr sz="1200" b="0">
+                <a:solidFill>
+                  <a:srgbClr val="000000"/>
+                </a:solidFill>
+              </a:rPr>
+              <a:t>[10] V. Sukumaran and S. Pavan, "Low Power Design Techniques for Single-Bit Audio CT Delta-Sigma ADCs Using FIR Feedback," IEEE JSSC, 49(11), 2014.</a:t>
+            </a:r>
+          </a:p>
+          <a:p>
+            <a:pPr algn="l"/>
+            <a:r>
+              <a:rPr sz="1200" b="0">
+                <a:solidFill>
+                  <a:srgbClr val="000000"/>
+                </a:solidFill>
+              </a:rPr>
+              <a:t>[11] Y. Zhang, et al., "A CT Delta-Sigma Modulator for Ultrasound Using Digital ELD Compensation and FIR Feedback," IEEE TCAS-I, 62(7), 2015.</a:t>
+            </a:r>
+          </a:p>
+          <a:p>
+            <a:pPr algn="l"/>
+            <a:r>
+              <a:rPr sz="1200" b="0">
+                <a:solidFill>
+                  <a:srgbClr val="000000"/>
+                </a:solidFill>
+              </a:rPr>
+              <a:t>[12] A. Jain and S. Pavan, "Continuous-Time Delta-Sigma Modulators With Time-Interleaved FIR Feedback," IEEE TCAS-I, 65(2), 2018.</a:t>
+            </a:r>
+          </a:p>
+          <a:p>
+            <a:pPr algn="l"/>
+            <a:r>
+              <a:rPr sz="1200" b="0">
+                <a:solidFill>
+                  <a:srgbClr val="000000"/>
+                </a:solidFill>
+              </a:rPr>
+              <a:t>[13] S. Billa, A. Dixit, and S. Pavan, "Analysis and Design of an Audio CT 1-X FIR-MASH Delta-Sigma Modulator," IEEE JSSC, 55(10), 2020.</a:t>
+            </a:r>
+          </a:p>
+          <a:p>
+            <a:pPr algn="l"/>
+            <a:r>
+              <a:rPr sz="1200" b="0">
+                <a:solidFill>
+                  <a:srgbClr val="000000"/>
+                </a:solidFill>
+              </a:rPr>
+              <a:t>[14] G. Theertham, et al., "Design of High-Resolution CT Delta-Sigma Data Converters With Dual Return-to-Open DACs," IEEE JSSC, 57(11), 2022.</a:t>
+            </a:r>
+          </a:p>
+        </p:txBody>
+      </p:sp>
     </p:spTree>
   </p:cSld>
   <p:clrMapOvr>
@@ -16570,7 +16797,7 @@
           <a:bodyPr wrap="square"/>
           <a:lstStyle/>
           <a:p>
-            <a:pPr/>
+            <a:pPr algn="l"/>
             <a:r>
               <a:rPr sz="1300" b="0">
                 <a:solidFill>
@@ -17046,7 +17273,7 @@
           </a:bodyPr>
           <a:lstStyle/>
           <a:p>
-            <a:pPr/>
+            <a:pPr algn="l"/>
             <a:r>
               <a:rPr sz="1300" b="1">
                 <a:solidFill>
@@ -17143,7 +17370,7 @@
           <a:bodyPr wrap="square"/>
           <a:lstStyle/>
           <a:p>
-            <a:pPr/>
+            <a:pPr algn="l"/>
             <a:r>
               <a:rPr sz="1600" b="1">
                 <a:solidFill>
@@ -17154,7 +17381,7 @@
             </a:r>
           </a:p>
           <a:p>
-            <a:pPr lvl="1"/>
+            <a:pPr lvl="1" algn="l"/>
             <a:r>
               <a:rPr sz="1300" b="0">
                 <a:solidFill>
@@ -17165,7 +17392,7 @@
             </a:r>
           </a:p>
           <a:p>
-            <a:pPr lvl="1"/>
+            <a:pPr lvl="1" algn="l"/>
             <a:r>
               <a:rPr sz="1300" b="0">
                 <a:solidFill>
@@ -17176,7 +17403,7 @@
             </a:r>
           </a:p>
           <a:p>
-            <a:pPr lvl="1"/>
+            <a:pPr lvl="1" algn="l"/>
             <a:r>
               <a:rPr sz="1300" b="0">
                 <a:solidFill>
@@ -17187,7 +17414,7 @@
             </a:r>
           </a:p>
           <a:p>
-            <a:pPr lvl="1"/>
+            <a:pPr lvl="1" algn="l"/>
             <a:r>
               <a:rPr sz="1300" b="0">
                 <a:solidFill>
@@ -17198,7 +17425,7 @@
             </a:r>
           </a:p>
           <a:p>
-            <a:pPr/>
+            <a:pPr algn="l"/>
             <a:r>
               <a:rPr sz="1300" b="1">
                 <a:solidFill>
@@ -17385,7 +17612,7 @@
           <a:bodyPr wrap="square"/>
           <a:lstStyle/>
           <a:p>
-            <a:pPr/>
+            <a:pPr algn="l"/>
             <a:r>
               <a:rPr sz="1600" b="1">
                 <a:solidFill>
@@ -17396,7 +17623,7 @@
             </a:r>
           </a:p>
           <a:p>
-            <a:pPr lvl="1"/>
+            <a:pPr lvl="1" algn="l"/>
             <a:r>
               <a:rPr sz="1300" b="0">
                 <a:solidFill>
@@ -17407,7 +17634,7 @@
             </a:r>
           </a:p>
           <a:p>
-            <a:pPr lvl="1"/>
+            <a:pPr lvl="1" algn="l"/>
             <a:r>
               <a:rPr sz="1300" b="0">
                 <a:solidFill>
@@ -17418,7 +17645,7 @@
             </a:r>
           </a:p>
           <a:p>
-            <a:pPr lvl="1"/>
+            <a:pPr lvl="1" algn="l"/>
             <a:r>
               <a:rPr sz="1300" b="0">
                 <a:solidFill>
@@ -17429,7 +17656,7 @@
             </a:r>
           </a:p>
           <a:p>
-            <a:pPr lvl="1"/>
+            <a:pPr lvl="1" algn="l"/>
             <a:r>
               <a:rPr sz="1300" b="0">
                 <a:solidFill>
@@ -17440,7 +17667,7 @@
             </a:r>
           </a:p>
           <a:p>
-            <a:pPr/>
+            <a:pPr algn="l"/>
             <a:r>
               <a:rPr sz="1300" b="1">
                 <a:solidFill>
@@ -17627,7 +17854,7 @@
           <a:bodyPr wrap="square"/>
           <a:lstStyle/>
           <a:p>
-            <a:pPr/>
+            <a:pPr algn="l"/>
             <a:r>
               <a:rPr sz="1600" b="1">
                 <a:solidFill>
@@ -17638,7 +17865,7 @@
             </a:r>
           </a:p>
           <a:p>
-            <a:pPr lvl="1"/>
+            <a:pPr lvl="1" algn="l"/>
             <a:r>
               <a:rPr sz="1300" b="0">
                 <a:solidFill>
@@ -17649,7 +17876,7 @@
             </a:r>
           </a:p>
           <a:p>
-            <a:pPr lvl="1"/>
+            <a:pPr lvl="1" algn="l"/>
             <a:r>
               <a:rPr sz="1300" b="0">
                 <a:solidFill>
@@ -17660,7 +17887,7 @@
             </a:r>
           </a:p>
           <a:p>
-            <a:pPr lvl="1"/>
+            <a:pPr lvl="1" algn="l"/>
             <a:r>
               <a:rPr sz="1300" b="0">
                 <a:solidFill>
@@ -17671,7 +17898,7 @@
             </a:r>
           </a:p>
           <a:p>
-            <a:pPr lvl="1"/>
+            <a:pPr lvl="1" algn="l"/>
             <a:r>
               <a:rPr sz="1300" b="0">
                 <a:solidFill>
@@ -17682,7 +17909,7 @@
             </a:r>
           </a:p>
           <a:p>
-            <a:pPr/>
+            <a:pPr algn="l"/>
             <a:r>
               <a:rPr sz="1300" b="1">
                 <a:solidFill>
@@ -17893,7 +18120,7 @@
           <a:bodyPr wrap="square"/>
           <a:lstStyle/>
           <a:p>
-            <a:pPr/>
+            <a:pPr algn="l"/>
             <a:r>
               <a:rPr sz="1200" b="0">
                 <a:solidFill>
@@ -18800,7 +19027,7 @@
           </a:bodyPr>
           <a:lstStyle/>
           <a:p>
-            <a:pPr/>
+            <a:pPr algn="l"/>
             <a:r>
               <a:rPr sz="1400" b="1">
                 <a:solidFill>
@@ -18811,7 +19038,7 @@
             </a:r>
           </a:p>
           <a:p>
-            <a:pPr lvl="1"/>
+            <a:pPr lvl="1" algn="l"/>
             <a:r>
               <a:rPr sz="1200" b="0">
                 <a:solidFill>
@@ -18822,7 +19049,7 @@
             </a:r>
           </a:p>
           <a:p>
-            <a:pPr lvl="1"/>
+            <a:pPr lvl="1" algn="l"/>
             <a:r>
               <a:rPr sz="1200" b="0">
                 <a:solidFill>
@@ -18833,7 +19060,7 @@
             </a:r>
           </a:p>
           <a:p>
-            <a:pPr lvl="1"/>
+            <a:pPr lvl="1" algn="l"/>
             <a:r>
               <a:rPr sz="1200" b="0">
                 <a:solidFill>
@@ -18844,7 +19071,7 @@
             </a:r>
           </a:p>
           <a:p>
-            <a:pPr lvl="1"/>
+            <a:pPr lvl="1" algn="l"/>
             <a:r>
               <a:rPr sz="1200" b="0">
                 <a:solidFill>
@@ -18855,7 +19082,7 @@
             </a:r>
           </a:p>
           <a:p>
-            <a:pPr lvl="1"/>
+            <a:pPr lvl="1" algn="l"/>
             <a:r>
               <a:rPr sz="1200" b="0">
                 <a:solidFill>
@@ -18866,7 +19093,7 @@
             </a:r>
           </a:p>
           <a:p>
-            <a:pPr lvl="1"/>
+            <a:pPr lvl="1" algn="l"/>
             <a:r>
               <a:rPr sz="1200" b="0">
                 <a:solidFill>
@@ -18877,7 +19104,7 @@
             </a:r>
           </a:p>
           <a:p>
-            <a:pPr/>
+            <a:pPr algn="l"/>
             <a:r>
               <a:rPr sz="1100" b="1">
                 <a:solidFill>
@@ -18976,7 +19203,7 @@
           </a:bodyPr>
           <a:lstStyle/>
           <a:p>
-            <a:pPr/>
+            <a:pPr algn="l"/>
             <a:r>
               <a:rPr sz="1300" b="0">
                 <a:solidFill>

</xml_diff>

<commit_message>
Update practical exam materials: replace PDF and PPTX files, enhance MATLAB scripts, and update result images
</commit_message>
<xml_diff>
--- a/practical-exam/Final_oral_exam_Daniel_Tyukov_5714699.pptx
+++ b/practical-exam/Final_oral_exam_Daniel_Tyukov_5714699.pptx
@@ -11050,7 +11050,7 @@
                   <a:srgbClr val="000000"/>
                 </a:solidFill>
               </a:rPr>
-              <a:t>Conclusion: ISI correction recovers peak SNDR ~71 -&gt; ~74 dB and drops HD2 ~15 dB (reproduces Figs 29/30).</a:t>
+              <a:t>Conclusion: ISI correction recovers peak SNDR ~71 -&gt; ~76 dB and drops HD2 ~15 dB (reproduces Figs 29/30; paper 74.3).</a:t>
             </a:r>
           </a:p>
         </p:txBody>
@@ -15237,7 +15237,7 @@
                   <a:srgbClr val="000000"/>
                 </a:solidFill>
               </a:rPr>
-              <a:t>Conclusion: First-tap-zero recovers ~52 -&gt; ~91 dB.</a:t>
+              <a:t>Conclusion: First-tap-zero recovers ~52 -&gt; ~94 dB (paper 91).</a:t>
             </a:r>
           </a:p>
         </p:txBody>
@@ -16884,8 +16884,8 @@
           <p:nvPr/>
         </p:nvGraphicFramePr>
         <p:xfrm>
-          <a:off x="411480" y="2194560"/>
-          <a:ext cx="5852160" cy="2743200"/>
+          <a:off x="411480" y="2286000"/>
+          <a:ext cx="6035040" cy="4023360"/>
         </p:xfrm>
         <a:graphic>
           <a:graphicData uri="http://schemas.openxmlformats.org/drawingml/2006/table">
@@ -16894,18 +16894,18 @@
                 <a:tableStyleId>{5C22544A-7EE6-4342-B048-85BDC9FD1C3A}</a:tableStyleId>
               </a:tblPr>
               <a:tblGrid>
-                <a:gridCol w="2834640"/>
-                <a:gridCol w="1645920"/>
+                <a:gridCol w="2926080"/>
+                <a:gridCol w="1737360"/>
                 <a:gridCol w="1371600"/>
               </a:tblGrid>
-              <a:tr h="548640">
+              <a:tr h="804672">
                 <a:tc>
                   <a:txBody>
                     <a:bodyPr/>
                     <a:lstStyle/>
                     <a:p>
                       <a:r>
-                        <a:rPr sz="1100" b="1">
+                        <a:rPr sz="1400" b="1">
                           <a:solidFill>
                             <a:srgbClr val="000000"/>
                           </a:solidFill>
@@ -16926,7 +16926,7 @@
                     <a:lstStyle/>
                     <a:p>
                       <a:r>
-                        <a:rPr sz="1100" b="1">
+                        <a:rPr sz="1400" b="1">
                           <a:solidFill>
                             <a:srgbClr val="000000"/>
                           </a:solidFill>
@@ -16947,7 +16947,7 @@
                     <a:lstStyle/>
                     <a:p>
                       <a:r>
-                        <a:rPr sz="1100" b="1">
+                        <a:rPr sz="1400" b="1">
                           <a:solidFill>
                             <a:srgbClr val="000000"/>
                           </a:solidFill>
@@ -16963,14 +16963,14 @@
                   </a:tcPr>
                 </a:tc>
               </a:tr>
-              <a:tr h="548640">
+              <a:tr h="804672">
                 <a:tc>
                   <a:txBody>
                     <a:bodyPr/>
                     <a:lstStyle/>
                     <a:p>
                       <a:r>
-                        <a:rPr sz="1100" b="0">
+                        <a:rPr sz="1400" b="0">
                           <a:solidFill>
                             <a:srgbClr val="000000"/>
                           </a:solidFill>
@@ -16991,7 +16991,7 @@
                     <a:lstStyle/>
                     <a:p>
                       <a:r>
-                        <a:rPr sz="1100" b="0">
+                        <a:rPr sz="1400" b="0">
                           <a:solidFill>
                             <a:srgbClr val="000000"/>
                           </a:solidFill>
@@ -17012,7 +17012,7 @@
                     <a:lstStyle/>
                     <a:p>
                       <a:r>
-                        <a:rPr sz="1100" b="0">
+                        <a:rPr sz="1400" b="0">
                           <a:solidFill>
                             <a:srgbClr val="000000"/>
                           </a:solidFill>
@@ -17028,14 +17028,14 @@
                   </a:tcPr>
                 </a:tc>
               </a:tr>
-              <a:tr h="548640">
+              <a:tr h="804672">
                 <a:tc>
                   <a:txBody>
                     <a:bodyPr/>
                     <a:lstStyle/>
                     <a:p>
                       <a:r>
-                        <a:rPr sz="1100" b="0">
+                        <a:rPr sz="1400" b="0">
                           <a:solidFill>
                             <a:srgbClr val="000000"/>
                           </a:solidFill>
@@ -17056,7 +17056,7 @@
                     <a:lstStyle/>
                     <a:p>
                       <a:r>
-                        <a:rPr sz="1100" b="0">
+                        <a:rPr sz="1400" b="0">
                           <a:solidFill>
                             <a:srgbClr val="000000"/>
                           </a:solidFill>
@@ -17077,12 +17077,12 @@
                     <a:lstStyle/>
                     <a:p>
                       <a:r>
-                        <a:rPr sz="1100" b="0">
+                        <a:rPr sz="1400" b="0">
                           <a:solidFill>
                             <a:srgbClr val="000000"/>
                           </a:solidFill>
                         </a:rPr>
-                        <a:t>~91 dB</a:t>
+                        <a:t>~94 dB</a:t>
                       </a:r>
                     </a:p>
                   </a:txBody>
@@ -17093,14 +17093,14 @@
                   </a:tcPr>
                 </a:tc>
               </a:tr>
-              <a:tr h="548640">
+              <a:tr h="804672">
                 <a:tc>
                   <a:txBody>
                     <a:bodyPr/>
                     <a:lstStyle/>
                     <a:p>
                       <a:r>
-                        <a:rPr sz="1100" b="0">
+                        <a:rPr sz="1400" b="0">
                           <a:solidFill>
                             <a:srgbClr val="000000"/>
                           </a:solidFill>
@@ -17121,7 +17121,7 @@
                     <a:lstStyle/>
                     <a:p>
                       <a:r>
-                        <a:rPr sz="1100" b="0">
+                        <a:rPr sz="1400" b="0">
                           <a:solidFill>
                             <a:srgbClr val="000000"/>
                           </a:solidFill>
@@ -17142,7 +17142,7 @@
                     <a:lstStyle/>
                     <a:p>
                       <a:r>
-                        <a:rPr sz="1100" b="0">
+                        <a:rPr sz="1400" b="0">
                           <a:solidFill>
                             <a:srgbClr val="000000"/>
                           </a:solidFill>
@@ -17158,14 +17158,14 @@
                   </a:tcPr>
                 </a:tc>
               </a:tr>
-              <a:tr h="548640">
+              <a:tr h="804672">
                 <a:tc>
                   <a:txBody>
                     <a:bodyPr/>
                     <a:lstStyle/>
                     <a:p>
                       <a:r>
-                        <a:rPr sz="1100" b="0">
+                        <a:rPr sz="1400" b="0">
                           <a:solidFill>
                             <a:srgbClr val="000000"/>
                           </a:solidFill>
@@ -17186,7 +17186,7 @@
                     <a:lstStyle/>
                     <a:p>
                       <a:r>
-                        <a:rPr sz="1100" b="0">
+                        <a:rPr sz="1400" b="0">
                           <a:solidFill>
                             <a:srgbClr val="000000"/>
                           </a:solidFill>
@@ -17207,7 +17207,7 @@
                     <a:lstStyle/>
                     <a:p>
                       <a:r>
-                        <a:rPr sz="1100" b="0">
+                        <a:rPr sz="1400" b="0">
                           <a:solidFill>
                             <a:srgbClr val="000000"/>
                           </a:solidFill>
@@ -17243,8 +17243,8 @@
         </p:blipFill>
         <p:spPr>
           <a:xfrm>
-            <a:off x="6492240" y="2359303"/>
-            <a:ext cx="6217920" cy="4059633"/>
+            <a:off x="6400800" y="2786653"/>
+            <a:ext cx="6309360" cy="4119334"/>
           </a:xfrm>
           <a:prstGeom prst="rect">
             <a:avLst/>
@@ -17259,7 +17259,7 @@
         </p:nvSpPr>
         <p:spPr>
           <a:xfrm>
-            <a:off x="411480" y="7498079"/>
+            <a:off x="411480" y="7680960"/>
             <a:ext cx="12252960" cy="914400"/>
           </a:xfrm>
           <a:prstGeom prst="rect">
@@ -17280,7 +17280,7 @@
                   <a:srgbClr val="000000"/>
                 </a:solidFill>
               </a:rPr>
-              <a:t>Conclusion: compensation = stability, first-tap-zero = +39 dB (metastability), FIR DAC = ~25 dB jitter-floor reduction.</a:t>
+              <a:t>Conclusion: compensation = stability, first-tap-zero = +42 dB (metastability), FIR DAC = ~25 dB jitter-floor reduction.</a:t>
             </a:r>
           </a:p>
         </p:txBody>
@@ -17363,7 +17363,7 @@
         <p:spPr>
           <a:xfrm>
             <a:off x="411480" y="1554480"/>
-            <a:ext cx="5852160" cy="6400800"/>
+            <a:ext cx="4754880" cy="5943600"/>
           </a:xfrm>
         </p:spPr>
         <p:txBody>
@@ -17399,7 +17399,7 @@
                   <a:srgbClr val="000000"/>
                 </a:solidFill>
               </a:rPr>
-              <a:t>Integrator output swings scaled to stay below ~0.45 (first-order path saturates last)</a:t>
+              <a:t>FIR DAC makes I4 see only the small shaped error (vin - v1): I4 has the smallest swing (~0.03)</a:t>
             </a:r>
           </a:p>
           <a:p>
@@ -17410,7 +17410,7 @@
                   <a:srgbClr val="000000"/>
                 </a:solidFill>
               </a:rPr>
-              <a:t>States map to the 1.2 V supply / Vref when expressed in volts</a:t>
+              <a:t>Swing grows toward the sign-only quantizer node I1; the first-order (input) path saturates last</a:t>
             </a:r>
           </a:p>
           <a:p>
@@ -17421,7 +17421,7 @@
                   <a:srgbClr val="000000"/>
                 </a:solidFill>
               </a:rPr>
-              <a:t>Scaling redistributes gain between integrators; the loop transfer is unchanged</a:t>
+              <a:t>States map to the 1.2 V supply / Vref; scaling redistributes gain, loop transfer unchanged</a:t>
             </a:r>
           </a:p>
           <a:p>
@@ -17432,7 +17432,7 @@
                   <a:srgbClr val="000000"/>
                 </a:solidFill>
               </a:rPr>
-              <a:t>Conclusion: scaling preserves the NTF/STF (1-bit modulator) and keeps every integrator swing inside the MSA.</a:t>
+              <a:t>Conclusion: the input integrator (most linearity-critical) has the smallest swing; scaling preserves the NTF/STF.</a:t>
             </a:r>
           </a:p>
         </p:txBody>
@@ -17519,8 +17519,8 @@
         </p:blipFill>
         <p:spPr>
           <a:xfrm>
-            <a:off x="6492240" y="2734225"/>
-            <a:ext cx="6217920" cy="4041309"/>
+            <a:off x="5120640" y="2318209"/>
+            <a:ext cx="7498079" cy="4873342"/>
           </a:xfrm>
           <a:prstGeom prst="rect">
             <a:avLst/>
@@ -17605,7 +17605,7 @@
         <p:spPr>
           <a:xfrm>
             <a:off x="411480" y="1554480"/>
-            <a:ext cx="5852160" cy="6400800"/>
+            <a:ext cx="4754880" cy="5943600"/>
           </a:xfrm>
         </p:spPr>
         <p:txBody>
@@ -17641,7 +17641,7 @@
                   <a:srgbClr val="000000"/>
                 </a:solidFill>
               </a:rPr>
-              <a:t>sigma sized so the in-band floor gives DR ~ 83 dB at 36 MHz (matches Table I)</a:t>
+              <a:t>sigma sized so the in-band floor sets the dynamic range (Table I target 83 dB)</a:t>
             </a:r>
           </a:p>
           <a:p>
@@ -17663,7 +17663,7 @@
                   <a:srgbClr val="000000"/>
                 </a:solidFill>
               </a:rPr>
-              <a:t>Output PSD scaled in dBFS by A*N/2 so it overlays the paper</a:t>
+              <a:t>Output PSD in true dBFS so it overlays the paper</a:t>
             </a:r>
           </a:p>
           <a:p>
@@ -17674,7 +17674,7 @@
                   <a:srgbClr val="000000"/>
                 </a:solidFill>
               </a:rPr>
-              <a:t>Conclusion: with the chosen input-referred noise the modulator reaches DR ~ 83 dB over 36 MHz.</a:t>
+              <a:t>Conclusion: with the chosen input-referred noise the modulator reaches DR ~ 80 dB over 36 MHz (paper 83).</a:t>
             </a:r>
           </a:p>
         </p:txBody>
@@ -17761,8 +17761,8 @@
         </p:blipFill>
         <p:spPr>
           <a:xfrm>
-            <a:off x="6492240" y="2725063"/>
-            <a:ext cx="6217920" cy="4059633"/>
+            <a:off x="5120640" y="2307160"/>
+            <a:ext cx="7498079" cy="4895439"/>
           </a:xfrm>
           <a:prstGeom prst="rect">
             <a:avLst/>
@@ -18228,7 +18228,7 @@
                     <a:lstStyle/>
                     <a:p>
                       <a:r>
-                        <a:rPr sz="1000" b="1">
+                        <a:rPr sz="1200" b="1">
                           <a:solidFill>
                             <a:srgbClr val="000000"/>
                           </a:solidFill>
@@ -18249,7 +18249,7 @@
                     <a:lstStyle/>
                     <a:p>
                       <a:r>
-                        <a:rPr sz="1000" b="1">
+                        <a:rPr sz="1200" b="1">
                           <a:solidFill>
                             <a:srgbClr val="000000"/>
                           </a:solidFill>
@@ -18270,7 +18270,7 @@
                     <a:lstStyle/>
                     <a:p>
                       <a:r>
-                        <a:rPr sz="1000" b="1">
+                        <a:rPr sz="1200" b="1">
                           <a:solidFill>
                             <a:srgbClr val="000000"/>
                           </a:solidFill>
@@ -18293,7 +18293,7 @@
                     <a:lstStyle/>
                     <a:p>
                       <a:r>
-                        <a:rPr sz="1000" b="0">
+                        <a:rPr sz="1200" b="0">
                           <a:solidFill>
                             <a:srgbClr val="000000"/>
                           </a:solidFill>
@@ -18314,7 +18314,7 @@
                     <a:lstStyle/>
                     <a:p>
                       <a:r>
-                        <a:rPr sz="1000" b="0">
+                        <a:rPr sz="1200" b="0">
                           <a:solidFill>
                             <a:srgbClr val="000000"/>
                           </a:solidFill>
@@ -18335,7 +18335,7 @@
                     <a:lstStyle/>
                     <a:p>
                       <a:r>
-                        <a:rPr sz="1000" b="0">
+                        <a:rPr sz="1200" b="0">
                           <a:solidFill>
                             <a:srgbClr val="000000"/>
                           </a:solidFill>
@@ -18358,7 +18358,7 @@
                     <a:lstStyle/>
                     <a:p>
                       <a:r>
-                        <a:rPr sz="1000" b="0">
+                        <a:rPr sz="1200" b="0">
                           <a:solidFill>
                             <a:srgbClr val="000000"/>
                           </a:solidFill>
@@ -18379,7 +18379,7 @@
                     <a:lstStyle/>
                     <a:p>
                       <a:r>
-                        <a:rPr sz="1000" b="0">
+                        <a:rPr sz="1200" b="0">
                           <a:solidFill>
                             <a:srgbClr val="000000"/>
                           </a:solidFill>
@@ -18400,7 +18400,7 @@
                     <a:lstStyle/>
                     <a:p>
                       <a:r>
-                        <a:rPr sz="1000" b="0">
+                        <a:rPr sz="1200" b="0">
                           <a:solidFill>
                             <a:srgbClr val="000000"/>
                           </a:solidFill>
@@ -18423,7 +18423,7 @@
                     <a:lstStyle/>
                     <a:p>
                       <a:r>
-                        <a:rPr sz="1000" b="0">
+                        <a:rPr sz="1200" b="0">
                           <a:solidFill>
                             <a:srgbClr val="000000"/>
                           </a:solidFill>
@@ -18444,7 +18444,7 @@
                     <a:lstStyle/>
                     <a:p>
                       <a:r>
-                        <a:rPr sz="1000" b="0">
+                        <a:rPr sz="1200" b="0">
                           <a:solidFill>
                             <a:srgbClr val="000000"/>
                           </a:solidFill>
@@ -18465,7 +18465,7 @@
                     <a:lstStyle/>
                     <a:p>
                       <a:r>
-                        <a:rPr sz="1000" b="0">
+                        <a:rPr sz="1200" b="0">
                           <a:solidFill>
                             <a:srgbClr val="000000"/>
                           </a:solidFill>
@@ -18488,7 +18488,7 @@
                     <a:lstStyle/>
                     <a:p>
                       <a:r>
-                        <a:rPr sz="1000" b="0">
+                        <a:rPr sz="1200" b="0">
                           <a:solidFill>
                             <a:srgbClr val="000000"/>
                           </a:solidFill>
@@ -18509,7 +18509,7 @@
                     <a:lstStyle/>
                     <a:p>
                       <a:r>
-                        <a:rPr sz="1000" b="0">
+                        <a:rPr sz="1200" b="0">
                           <a:solidFill>
                             <a:srgbClr val="000000"/>
                           </a:solidFill>
@@ -18530,7 +18530,7 @@
                     <a:lstStyle/>
                     <a:p>
                       <a:r>
-                        <a:rPr sz="1000" b="0">
+                        <a:rPr sz="1200" b="0">
                           <a:solidFill>
                             <a:srgbClr val="000000"/>
                           </a:solidFill>
@@ -18553,7 +18553,7 @@
                     <a:lstStyle/>
                     <a:p>
                       <a:r>
-                        <a:rPr sz="1000" b="0">
+                        <a:rPr sz="1200" b="0">
                           <a:solidFill>
                             <a:srgbClr val="000000"/>
                           </a:solidFill>
@@ -18574,7 +18574,7 @@
                     <a:lstStyle/>
                     <a:p>
                       <a:r>
-                        <a:rPr sz="1000" b="0">
+                        <a:rPr sz="1200" b="0">
                           <a:solidFill>
                             <a:srgbClr val="000000"/>
                           </a:solidFill>
@@ -18595,7 +18595,7 @@
                     <a:lstStyle/>
                     <a:p>
                       <a:r>
-                        <a:rPr sz="1000" b="0">
+                        <a:rPr sz="1200" b="0">
                           <a:solidFill>
                             <a:srgbClr val="000000"/>
                           </a:solidFill>
@@ -18618,7 +18618,7 @@
                     <a:lstStyle/>
                     <a:p>
                       <a:r>
-                        <a:rPr sz="1000" b="0">
+                        <a:rPr sz="1200" b="0">
                           <a:solidFill>
                             <a:srgbClr val="000000"/>
                           </a:solidFill>
@@ -18639,7 +18639,7 @@
                     <a:lstStyle/>
                     <a:p>
                       <a:r>
-                        <a:rPr sz="1000" b="0">
+                        <a:rPr sz="1200" b="0">
                           <a:solidFill>
                             <a:srgbClr val="000000"/>
                           </a:solidFill>
@@ -18660,7 +18660,7 @@
                     <a:lstStyle/>
                     <a:p>
                       <a:r>
-                        <a:rPr sz="1000" b="0">
+                        <a:rPr sz="1200" b="0">
                           <a:solidFill>
                             <a:srgbClr val="000000"/>
                           </a:solidFill>
@@ -18683,7 +18683,7 @@
                     <a:lstStyle/>
                     <a:p>
                       <a:r>
-                        <a:rPr sz="1000" b="0">
+                        <a:rPr sz="1200" b="0">
                           <a:solidFill>
                             <a:srgbClr val="000000"/>
                           </a:solidFill>
@@ -18704,7 +18704,7 @@
                     <a:lstStyle/>
                     <a:p>
                       <a:r>
-                        <a:rPr sz="1000" b="0">
+                        <a:rPr sz="1200" b="0">
                           <a:solidFill>
                             <a:srgbClr val="000000"/>
                           </a:solidFill>
@@ -18725,7 +18725,7 @@
                     <a:lstStyle/>
                     <a:p>
                       <a:r>
-                        <a:rPr sz="1000" b="0">
+                        <a:rPr sz="1200" b="0">
                           <a:solidFill>
                             <a:srgbClr val="000000"/>
                           </a:solidFill>
@@ -18748,7 +18748,7 @@
                     <a:lstStyle/>
                     <a:p>
                       <a:r>
-                        <a:rPr sz="1000" b="0">
+                        <a:rPr sz="1200" b="0">
                           <a:solidFill>
                             <a:srgbClr val="000000"/>
                           </a:solidFill>
@@ -18769,12 +18769,12 @@
                     <a:lstStyle/>
                     <a:p>
                       <a:r>
-                        <a:rPr sz="1000" b="0">
+                        <a:rPr sz="1200" b="0">
                           <a:solidFill>
                             <a:srgbClr val="000000"/>
                           </a:solidFill>
                         </a:rPr>
-                        <a:t>52 -&gt; 91 dB</a:t>
+                        <a:t>52 -&gt; 94 dB (paper 91)</a:t>
                       </a:r>
                     </a:p>
                   </a:txBody>
@@ -18790,7 +18790,7 @@
                     <a:lstStyle/>
                     <a:p>
                       <a:r>
-                        <a:rPr sz="1000" b="0">
+                        <a:rPr sz="1200" b="0">
                           <a:solidFill>
                             <a:srgbClr val="000000"/>
                           </a:solidFill>
@@ -18813,7 +18813,7 @@
                     <a:lstStyle/>
                     <a:p>
                       <a:r>
-                        <a:rPr sz="1000" b="0">
+                        <a:rPr sz="1200" b="0">
                           <a:solidFill>
                             <a:srgbClr val="000000"/>
                           </a:solidFill>
@@ -18834,7 +18834,7 @@
                     <a:lstStyle/>
                     <a:p>
                       <a:r>
-                        <a:rPr sz="1000" b="0">
+                        <a:rPr sz="1200" b="0">
                           <a:solidFill>
                             <a:srgbClr val="000000"/>
                           </a:solidFill>
@@ -18855,7 +18855,7 @@
                     <a:lstStyle/>
                     <a:p>
                       <a:r>
-                        <a:rPr sz="1000" b="0">
+                        <a:rPr sz="1200" b="0">
                           <a:solidFill>
                             <a:srgbClr val="000000"/>
                           </a:solidFill>
@@ -18878,7 +18878,7 @@
                     <a:lstStyle/>
                     <a:p>
                       <a:r>
-                        <a:rPr sz="1000" b="0">
+                        <a:rPr sz="1200" b="0">
                           <a:solidFill>
                             <a:srgbClr val="000000"/>
                           </a:solidFill>
@@ -18899,7 +18899,7 @@
                     <a:lstStyle/>
                     <a:p>
                       <a:r>
-                        <a:rPr sz="1000" b="0">
+                        <a:rPr sz="1200" b="0">
                           <a:solidFill>
                             <a:srgbClr val="000000"/>
                           </a:solidFill>
@@ -18920,7 +18920,7 @@
                     <a:lstStyle/>
                     <a:p>
                       <a:r>
-                        <a:rPr sz="1000" b="0">
+                        <a:rPr sz="1200" b="0">
                           <a:solidFill>
                             <a:srgbClr val="000000"/>
                           </a:solidFill>
@@ -18943,7 +18943,7 @@
                     <a:lstStyle/>
                     <a:p>
                       <a:r>
-                        <a:rPr sz="1000" b="0">
+                        <a:rPr sz="1200" b="0">
                           <a:solidFill>
                             <a:srgbClr val="000000"/>
                           </a:solidFill>
@@ -18964,7 +18964,7 @@
                     <a:lstStyle/>
                     <a:p>
                       <a:r>
-                        <a:rPr sz="1000" b="0">
+                        <a:rPr sz="1200" b="0">
                           <a:solidFill>
                             <a:srgbClr val="000000"/>
                           </a:solidFill>
@@ -18985,7 +18985,7 @@
                     <a:lstStyle/>
                     <a:p>
                       <a:r>
-                        <a:rPr sz="1000" b="0">
+                        <a:rPr sz="1200" b="0">
                           <a:solidFill>
                             <a:srgbClr val="000000"/>
                           </a:solidFill>

</xml_diff>

<commit_message>
Update practical exam materials: replace PDF and PPTX files, and enhance MATLAB script content
</commit_message>
<xml_diff>
--- a/practical-exam/Final_oral_exam_Daniel_Tyukov_5714699.pptx
+++ b/practical-exam/Final_oral_exam_Daniel_Tyukov_5714699.pptx
@@ -6933,7 +6933,7 @@
                   <a:srgbClr val="000000"/>
                 </a:solidFill>
               </a:rPr>
-              <a:t>The 8-tap FIR DAC has unit-element (resistor) mismatch; chose sigma ~ 0.5-1% per tap.</a:t>
+              <a:t>The 8-tap FIR DAC has unit-element (resistor) mismatch; plot shows 2% sigma per tap (exaggerated; realistic ~0.5-1%) to make the zero shift visible.</a:t>
             </a:r>
           </a:p>
           <a:p>
@@ -7850,7 +7850,7 @@
                   <a:srgbClr val="000000"/>
                 </a:solidFill>
               </a:rPr>
-              <a:t>Paper: weak cubic on the input integrator I4: i = Gm*vd - G3*vd^3 (Gm/G3 = 1000, '20,20'; Fig 3).</a:t>
+              <a:t>Paper: weak cubic on the input integrator I4: i = Gm*vd - G3*vd^3; swept G3 = 0 / 0.1 / 0.3 (Fig 3).</a:t>
             </a:r>
           </a:p>
           <a:p>
@@ -9180,14 +9180,14 @@
                 <a:tableStyleId>{5C22544A-7EE6-4342-B048-85BDC9FD1C3A}</a:tableStyleId>
               </a:tblPr>
               <a:tblGrid>
-                <a:gridCol w="1737360"/>
+                <a:gridCol w="2103120"/>
                 <a:gridCol w="1737360"/>
                 <a:gridCol w="1005840"/>
                 <a:gridCol w="914400"/>
                 <a:gridCol w="1005840"/>
                 <a:gridCol w="1097280"/>
                 <a:gridCol w="1005840"/>
-                <a:gridCol w="3931920"/>
+                <a:gridCol w="3566160"/>
               </a:tblGrid>
               <a:tr h="617220">
                 <a:tc>
@@ -9371,7 +9371,7 @@
                             <a:srgbClr val="000000"/>
                           </a:solidFill>
                         </a:rPr>
-                        <a:t>This work '12</a:t>
+                        <a:t>This work '12 [1]</a:t>
                       </a:r>
                     </a:p>
                   </a:txBody>
@@ -9434,7 +9434,7 @@
                             <a:srgbClr val="000000"/>
                           </a:solidFill>
                         </a:rPr>
-                        <a:t>86@25M</a:t>
+                        <a:t>83</a:t>
                       </a:r>
                     </a:p>
                   </a:txBody>
@@ -9455,7 +9455,7 @@
                             <a:srgbClr val="000000"/>
                           </a:solidFill>
                         </a:rPr>
-                        <a:t>71@36M</a:t>
+                        <a:t>70.9</a:t>
                       </a:r>
                     </a:p>
                   </a:txBody>
@@ -9541,7 +9541,7 @@
                             <a:srgbClr val="000000"/>
                           </a:solidFill>
                         </a:rPr>
-                        <a:t>Bolatkale '11 [6]</a:t>
+                        <a:t>Bolatkale '11 [9]</a:t>
                       </a:r>
                     </a:p>
                   </a:txBody>
@@ -9711,7 +9711,7 @@
                             <a:srgbClr val="000000"/>
                           </a:solidFill>
                         </a:rPr>
-                        <a:t>Sukumaran '14</a:t>
+                        <a:t>Sukumaran '14 [10]</a:t>
                       </a:r>
                     </a:p>
                   </a:txBody>
@@ -9881,7 +9881,7 @@
                             <a:srgbClr val="000000"/>
                           </a:solidFill>
                         </a:rPr>
-                        <a:t>Zhang-Temes '15</a:t>
+                        <a:t>Zhang-Temes '15 [11]</a:t>
                       </a:r>
                     </a:p>
                   </a:txBody>
@@ -10051,7 +10051,7 @@
                             <a:srgbClr val="000000"/>
                           </a:solidFill>
                         </a:rPr>
-                        <a:t>Jain-Pavan '18</a:t>
+                        <a:t>Jain-Pavan '18 [12]</a:t>
                       </a:r>
                     </a:p>
                   </a:txBody>
@@ -10221,7 +10221,7 @@
                             <a:srgbClr val="000000"/>
                           </a:solidFill>
                         </a:rPr>
-                        <a:t>Billa '20</a:t>
+                        <a:t>Billa '20 [13]</a:t>
                       </a:r>
                     </a:p>
                   </a:txBody>
@@ -10391,7 +10391,7 @@
                             <a:srgbClr val="000000"/>
                           </a:solidFill>
                         </a:rPr>
-                        <a:t>Theertham '22</a:t>
+                        <a:t>Theertham '22 [14]</a:t>
                       </a:r>
                     </a:p>
                   </a:txBody>
@@ -12670,7 +12670,7 @@
                   <a:srgbClr val="000000"/>
                 </a:solidFill>
               </a:rPr>
-              <a:t>Supplies the low-jitter 3.6 GHz clock; simulated VCO phase noise ~ -120 dBc/Hz @ 1 MHz.</a:t>
+              <a:t>Supplies the low-jitter 3.6 GHz clock; LC-VCO phase noise (~-120 dBc/Hz @ 1 MHz class) sets the jitter floor.</a:t>
             </a:r>
           </a:p>
           <a:p>
@@ -15485,7 +15485,7 @@
                   <a:srgbClr val="000000"/>
                 </a:solidFill>
               </a:rPr>
-              <a:t>F(z) from Eq.(1); E(z) = (1 - F(z))/(1 - z^-1) (DC gain 0)</a:t>
+              <a:t>F(z) from Eq.(1); E(z) = (1 - F(z))/(1 - z^-1); 1-F has a DC zero so comp stays out-of-band</a:t>
             </a:r>
           </a:p>
           <a:p>
@@ -17362,8 +17362,8 @@
         </p:nvSpPr>
         <p:spPr>
           <a:xfrm>
-            <a:off x="411480" y="1554480"/>
-            <a:ext cx="4754880" cy="5943600"/>
+            <a:off x="411480" y="1417320"/>
+            <a:ext cx="12252960" cy="1920240"/>
           </a:xfrm>
         </p:spPr>
         <p:txBody>
@@ -17519,8 +17519,8 @@
         </p:blipFill>
         <p:spPr>
           <a:xfrm>
-            <a:off x="5120640" y="2318209"/>
-            <a:ext cx="7498079" cy="4873342"/>
+            <a:off x="2130890" y="3383280"/>
+            <a:ext cx="8722700" cy="5669280"/>
           </a:xfrm>
           <a:prstGeom prst="rect">
             <a:avLst/>
@@ -17604,8 +17604,8 @@
         </p:nvSpPr>
         <p:spPr>
           <a:xfrm>
-            <a:off x="411480" y="1554480"/>
-            <a:ext cx="4754880" cy="5943600"/>
+            <a:off x="411480" y="1417320"/>
+            <a:ext cx="12252960" cy="1920240"/>
           </a:xfrm>
         </p:spPr>
         <p:txBody>
@@ -17761,8 +17761,8 @@
         </p:blipFill>
         <p:spPr>
           <a:xfrm>
-            <a:off x="5120640" y="2307160"/>
-            <a:ext cx="7498079" cy="4895439"/>
+            <a:off x="2150576" y="3383280"/>
+            <a:ext cx="8683327" cy="5669280"/>
           </a:xfrm>
           <a:prstGeom prst="rect">
             <a:avLst/>
@@ -17846,8 +17846,8 @@
         </p:nvSpPr>
         <p:spPr>
           <a:xfrm>
-            <a:off x="411480" y="1554480"/>
-            <a:ext cx="5120640" cy="6400800"/>
+            <a:off x="411480" y="1417320"/>
+            <a:ext cx="12252960" cy="1737360"/>
           </a:xfrm>
         </p:spPr>
         <p:txBody>
@@ -17905,7 +17905,7 @@
                   <a:srgbClr val="000000"/>
                 </a:solidFill>
               </a:rPr>
-              <a:t>(bitstream, integrator states, recovered sine)</a:t>
+              <a:t>(bitstream, FIR DAC feedback, recovered sine)</a:t>
             </a:r>
           </a:p>
           <a:p>
@@ -18003,8 +18003,8 @@
         </p:blipFill>
         <p:spPr>
           <a:xfrm>
-            <a:off x="6275793" y="1463040"/>
-            <a:ext cx="5462093" cy="3566160"/>
+            <a:off x="457200" y="3340961"/>
+            <a:ext cx="7132320" cy="4656638"/>
           </a:xfrm>
           <a:prstGeom prst="rect">
             <a:avLst/>
@@ -18027,8 +18027,8 @@
         </p:blipFill>
         <p:spPr>
           <a:xfrm>
-            <a:off x="6588690" y="5029200"/>
-            <a:ext cx="4836299" cy="3566160"/>
+            <a:off x="7406640" y="3543069"/>
+            <a:ext cx="5394960" cy="3978101"/>
           </a:xfrm>
           <a:prstGeom prst="rect">
             <a:avLst/>
@@ -18113,7 +18113,7 @@
         <p:spPr>
           <a:xfrm>
             <a:off x="411480" y="1554480"/>
-            <a:ext cx="7863840" cy="365760"/>
+            <a:ext cx="12252960" cy="365760"/>
           </a:xfrm>
         </p:spPr>
         <p:txBody>
@@ -18122,7 +18122,7 @@
           <a:p>
             <a:pPr algn="l"/>
             <a:r>
-              <a:rPr sz="1200" b="0">
+              <a:rPr sz="1300" b="0">
                 <a:solidFill>
                   <a:srgbClr val="000000"/>
                 </a:solidFill>
@@ -18207,8 +18207,8 @@
           <p:nvPr/>
         </p:nvGraphicFramePr>
         <p:xfrm>
-          <a:off x="411480" y="2011680"/>
-          <a:ext cx="7955280" cy="6035040"/>
+          <a:off x="411480" y="1965960"/>
+          <a:ext cx="8869680" cy="7406640"/>
         </p:xfrm>
         <a:graphic>
           <a:graphicData uri="http://schemas.openxmlformats.org/drawingml/2006/table">
@@ -18217,18 +18217,18 @@
                 <a:tableStyleId>{5C22544A-7EE6-4342-B048-85BDC9FD1C3A}</a:tableStyleId>
               </a:tblPr>
               <a:tblGrid>
-                <a:gridCol w="2651760"/>
-                <a:gridCol w="4023360"/>
-                <a:gridCol w="1280160"/>
+                <a:gridCol w="3017520"/>
+                <a:gridCol w="4389120"/>
+                <a:gridCol w="1463040"/>
               </a:tblGrid>
-              <a:tr h="502920">
+              <a:tr h="617220">
                 <a:tc>
                   <a:txBody>
                     <a:bodyPr/>
                     <a:lstStyle/>
                     <a:p>
                       <a:r>
-                        <a:rPr sz="1200" b="1">
+                        <a:rPr sz="1400" b="1">
                           <a:solidFill>
                             <a:srgbClr val="000000"/>
                           </a:solidFill>
@@ -18249,7 +18249,7 @@
                     <a:lstStyle/>
                     <a:p>
                       <a:r>
-                        <a:rPr sz="1200" b="1">
+                        <a:rPr sz="1400" b="1">
                           <a:solidFill>
                             <a:srgbClr val="000000"/>
                           </a:solidFill>
@@ -18270,7 +18270,7 @@
                     <a:lstStyle/>
                     <a:p>
                       <a:r>
-                        <a:rPr sz="1200" b="1">
+                        <a:rPr sz="1400" b="1">
                           <a:solidFill>
                             <a:srgbClr val="000000"/>
                           </a:solidFill>
@@ -18286,14 +18286,14 @@
                   </a:tcPr>
                 </a:tc>
               </a:tr>
-              <a:tr h="502920">
+              <a:tr h="617220">
                 <a:tc>
                   <a:txBody>
                     <a:bodyPr/>
                     <a:lstStyle/>
                     <a:p>
                       <a:r>
-                        <a:rPr sz="1200" b="0">
+                        <a:rPr sz="1400" b="0">
                           <a:solidFill>
                             <a:srgbClr val="000000"/>
                           </a:solidFill>
@@ -18314,7 +18314,7 @@
                     <a:lstStyle/>
                     <a:p>
                       <a:r>
-                        <a:rPr sz="1200" b="0">
+                        <a:rPr sz="1400" b="0">
                           <a:solidFill>
                             <a:srgbClr val="000000"/>
                           </a:solidFill>
@@ -18335,7 +18335,7 @@
                     <a:lstStyle/>
                     <a:p>
                       <a:r>
-                        <a:rPr sz="1200" b="0">
+                        <a:rPr sz="1400" b="0">
                           <a:solidFill>
                             <a:srgbClr val="000000"/>
                           </a:solidFill>
@@ -18351,14 +18351,14 @@
                   </a:tcPr>
                 </a:tc>
               </a:tr>
-              <a:tr h="502920">
+              <a:tr h="617220">
                 <a:tc>
                   <a:txBody>
                     <a:bodyPr/>
                     <a:lstStyle/>
                     <a:p>
                       <a:r>
-                        <a:rPr sz="1200" b="0">
+                        <a:rPr sz="1400" b="0">
                           <a:solidFill>
                             <a:srgbClr val="000000"/>
                           </a:solidFill>
@@ -18379,7 +18379,7 @@
                     <a:lstStyle/>
                     <a:p>
                       <a:r>
-                        <a:rPr sz="1200" b="0">
+                        <a:rPr sz="1400" b="0">
                           <a:solidFill>
                             <a:srgbClr val="000000"/>
                           </a:solidFill>
@@ -18400,7 +18400,7 @@
                     <a:lstStyle/>
                     <a:p>
                       <a:r>
-                        <a:rPr sz="1200" b="0">
+                        <a:rPr sz="1400" b="0">
                           <a:solidFill>
                             <a:srgbClr val="000000"/>
                           </a:solidFill>
@@ -18416,14 +18416,14 @@
                   </a:tcPr>
                 </a:tc>
               </a:tr>
-              <a:tr h="502920">
+              <a:tr h="617220">
                 <a:tc>
                   <a:txBody>
                     <a:bodyPr/>
                     <a:lstStyle/>
                     <a:p>
                       <a:r>
-                        <a:rPr sz="1200" b="0">
+                        <a:rPr sz="1400" b="0">
                           <a:solidFill>
                             <a:srgbClr val="000000"/>
                           </a:solidFill>
@@ -18444,7 +18444,7 @@
                     <a:lstStyle/>
                     <a:p>
                       <a:r>
-                        <a:rPr sz="1200" b="0">
+                        <a:rPr sz="1400" b="0">
                           <a:solidFill>
                             <a:srgbClr val="000000"/>
                           </a:solidFill>
@@ -18465,7 +18465,7 @@
                     <a:lstStyle/>
                     <a:p>
                       <a:r>
-                        <a:rPr sz="1200" b="0">
+                        <a:rPr sz="1400" b="0">
                           <a:solidFill>
                             <a:srgbClr val="000000"/>
                           </a:solidFill>
@@ -18481,14 +18481,14 @@
                   </a:tcPr>
                 </a:tc>
               </a:tr>
-              <a:tr h="502920">
+              <a:tr h="617220">
                 <a:tc>
                   <a:txBody>
                     <a:bodyPr/>
                     <a:lstStyle/>
                     <a:p>
                       <a:r>
-                        <a:rPr sz="1200" b="0">
+                        <a:rPr sz="1400" b="0">
                           <a:solidFill>
                             <a:srgbClr val="000000"/>
                           </a:solidFill>
@@ -18509,7 +18509,7 @@
                     <a:lstStyle/>
                     <a:p>
                       <a:r>
-                        <a:rPr sz="1200" b="0">
+                        <a:rPr sz="1400" b="0">
                           <a:solidFill>
                             <a:srgbClr val="000000"/>
                           </a:solidFill>
@@ -18530,7 +18530,7 @@
                     <a:lstStyle/>
                     <a:p>
                       <a:r>
-                        <a:rPr sz="1200" b="0">
+                        <a:rPr sz="1400" b="0">
                           <a:solidFill>
                             <a:srgbClr val="000000"/>
                           </a:solidFill>
@@ -18546,14 +18546,14 @@
                   </a:tcPr>
                 </a:tc>
               </a:tr>
-              <a:tr h="502920">
+              <a:tr h="617220">
                 <a:tc>
                   <a:txBody>
                     <a:bodyPr/>
                     <a:lstStyle/>
                     <a:p>
                       <a:r>
-                        <a:rPr sz="1200" b="0">
+                        <a:rPr sz="1400" b="0">
                           <a:solidFill>
                             <a:srgbClr val="000000"/>
                           </a:solidFill>
@@ -18574,7 +18574,7 @@
                     <a:lstStyle/>
                     <a:p>
                       <a:r>
-                        <a:rPr sz="1200" b="0">
+                        <a:rPr sz="1400" b="0">
                           <a:solidFill>
                             <a:srgbClr val="000000"/>
                           </a:solidFill>
@@ -18595,7 +18595,7 @@
                     <a:lstStyle/>
                     <a:p>
                       <a:r>
-                        <a:rPr sz="1200" b="0">
+                        <a:rPr sz="1400" b="0">
                           <a:solidFill>
                             <a:srgbClr val="000000"/>
                           </a:solidFill>
@@ -18611,14 +18611,14 @@
                   </a:tcPr>
                 </a:tc>
               </a:tr>
-              <a:tr h="502920">
+              <a:tr h="617220">
                 <a:tc>
                   <a:txBody>
                     <a:bodyPr/>
                     <a:lstStyle/>
                     <a:p>
                       <a:r>
-                        <a:rPr sz="1200" b="0">
+                        <a:rPr sz="1400" b="0">
                           <a:solidFill>
                             <a:srgbClr val="000000"/>
                           </a:solidFill>
@@ -18639,7 +18639,7 @@
                     <a:lstStyle/>
                     <a:p>
                       <a:r>
-                        <a:rPr sz="1200" b="0">
+                        <a:rPr sz="1400" b="0">
                           <a:solidFill>
                             <a:srgbClr val="000000"/>
                           </a:solidFill>
@@ -18660,7 +18660,7 @@
                     <a:lstStyle/>
                     <a:p>
                       <a:r>
-                        <a:rPr sz="1200" b="0">
+                        <a:rPr sz="1400" b="0">
                           <a:solidFill>
                             <a:srgbClr val="000000"/>
                           </a:solidFill>
@@ -18676,14 +18676,14 @@
                   </a:tcPr>
                 </a:tc>
               </a:tr>
-              <a:tr h="502920">
+              <a:tr h="617220">
                 <a:tc>
                   <a:txBody>
                     <a:bodyPr/>
                     <a:lstStyle/>
                     <a:p>
                       <a:r>
-                        <a:rPr sz="1200" b="0">
+                        <a:rPr sz="1400" b="0">
                           <a:solidFill>
                             <a:srgbClr val="000000"/>
                           </a:solidFill>
@@ -18704,7 +18704,7 @@
                     <a:lstStyle/>
                     <a:p>
                       <a:r>
-                        <a:rPr sz="1200" b="0">
+                        <a:rPr sz="1400" b="0">
                           <a:solidFill>
                             <a:srgbClr val="000000"/>
                           </a:solidFill>
@@ -18725,7 +18725,7 @@
                     <a:lstStyle/>
                     <a:p>
                       <a:r>
-                        <a:rPr sz="1200" b="0">
+                        <a:rPr sz="1400" b="0">
                           <a:solidFill>
                             <a:srgbClr val="000000"/>
                           </a:solidFill>
@@ -18741,14 +18741,14 @@
                   </a:tcPr>
                 </a:tc>
               </a:tr>
-              <a:tr h="502920">
+              <a:tr h="617220">
                 <a:tc>
                   <a:txBody>
                     <a:bodyPr/>
                     <a:lstStyle/>
                     <a:p>
                       <a:r>
-                        <a:rPr sz="1200" b="0">
+                        <a:rPr sz="1400" b="0">
                           <a:solidFill>
                             <a:srgbClr val="000000"/>
                           </a:solidFill>
@@ -18769,7 +18769,7 @@
                     <a:lstStyle/>
                     <a:p>
                       <a:r>
-                        <a:rPr sz="1200" b="0">
+                        <a:rPr sz="1400" b="0">
                           <a:solidFill>
                             <a:srgbClr val="000000"/>
                           </a:solidFill>
@@ -18790,7 +18790,7 @@
                     <a:lstStyle/>
                     <a:p>
                       <a:r>
-                        <a:rPr sz="1200" b="0">
+                        <a:rPr sz="1400" b="0">
                           <a:solidFill>
                             <a:srgbClr val="000000"/>
                           </a:solidFill>
@@ -18806,14 +18806,14 @@
                   </a:tcPr>
                 </a:tc>
               </a:tr>
-              <a:tr h="502920">
+              <a:tr h="617220">
                 <a:tc>
                   <a:txBody>
                     <a:bodyPr/>
                     <a:lstStyle/>
                     <a:p>
                       <a:r>
-                        <a:rPr sz="1200" b="0">
+                        <a:rPr sz="1400" b="0">
                           <a:solidFill>
                             <a:srgbClr val="000000"/>
                           </a:solidFill>
@@ -18834,7 +18834,7 @@
                     <a:lstStyle/>
                     <a:p>
                       <a:r>
-                        <a:rPr sz="1200" b="0">
+                        <a:rPr sz="1400" b="0">
                           <a:solidFill>
                             <a:srgbClr val="000000"/>
                           </a:solidFill>
@@ -18855,7 +18855,7 @@
                     <a:lstStyle/>
                     <a:p>
                       <a:r>
-                        <a:rPr sz="1200" b="0">
+                        <a:rPr sz="1400" b="0">
                           <a:solidFill>
                             <a:srgbClr val="000000"/>
                           </a:solidFill>
@@ -18871,14 +18871,14 @@
                   </a:tcPr>
                 </a:tc>
               </a:tr>
-              <a:tr h="502920">
+              <a:tr h="617220">
                 <a:tc>
                   <a:txBody>
                     <a:bodyPr/>
                     <a:lstStyle/>
                     <a:p>
                       <a:r>
-                        <a:rPr sz="1200" b="0">
+                        <a:rPr sz="1400" b="0">
                           <a:solidFill>
                             <a:srgbClr val="000000"/>
                           </a:solidFill>
@@ -18899,7 +18899,7 @@
                     <a:lstStyle/>
                     <a:p>
                       <a:r>
-                        <a:rPr sz="1200" b="0">
+                        <a:rPr sz="1400" b="0">
                           <a:solidFill>
                             <a:srgbClr val="000000"/>
                           </a:solidFill>
@@ -18920,7 +18920,7 @@
                     <a:lstStyle/>
                     <a:p>
                       <a:r>
-                        <a:rPr sz="1200" b="0">
+                        <a:rPr sz="1400" b="0">
                           <a:solidFill>
                             <a:srgbClr val="000000"/>
                           </a:solidFill>
@@ -18936,14 +18936,14 @@
                   </a:tcPr>
                 </a:tc>
               </a:tr>
-              <a:tr h="502920">
+              <a:tr h="617220">
                 <a:tc>
                   <a:txBody>
                     <a:bodyPr/>
                     <a:lstStyle/>
                     <a:p>
                       <a:r>
-                        <a:rPr sz="1200" b="0">
+                        <a:rPr sz="1400" b="0">
                           <a:solidFill>
                             <a:srgbClr val="000000"/>
                           </a:solidFill>
@@ -18964,7 +18964,7 @@
                     <a:lstStyle/>
                     <a:p>
                       <a:r>
-                        <a:rPr sz="1200" b="0">
+                        <a:rPr sz="1400" b="0">
                           <a:solidFill>
                             <a:srgbClr val="000000"/>
                           </a:solidFill>
@@ -18985,7 +18985,7 @@
                     <a:lstStyle/>
                     <a:p>
                       <a:r>
-                        <a:rPr sz="1200" b="0">
+                        <a:rPr sz="1400" b="0">
                           <a:solidFill>
                             <a:srgbClr val="000000"/>
                           </a:solidFill>
@@ -19013,8 +19013,8 @@
         </p:nvSpPr>
         <p:spPr>
           <a:xfrm>
-            <a:off x="8503920" y="2011680"/>
-            <a:ext cx="4114800" cy="6035040"/>
+            <a:off x="9509760" y="1965960"/>
+            <a:ext cx="3291840" cy="7406640"/>
           </a:xfrm>
           <a:prstGeom prst="rect">
             <a:avLst/>
@@ -19029,7 +19029,7 @@
           <a:p>
             <a:pPr algn="l"/>
             <a:r>
-              <a:rPr sz="1400" b="1">
+              <a:rPr sz="1500" b="1">
                 <a:solidFill>
                   <a:srgbClr val="000000"/>
                 </a:solidFill>
@@ -19040,7 +19040,7 @@
           <a:p>
             <a:pPr lvl="1" algn="l"/>
             <a:r>
-              <a:rPr sz="1200" b="0">
+              <a:rPr sz="1300" b="0">
                 <a:solidFill>
                   <a:srgbClr val="000000"/>
                 </a:solidFill>
@@ -19051,7 +19051,7 @@
           <a:p>
             <a:pPr lvl="1" algn="l"/>
             <a:r>
-              <a:rPr sz="1200" b="0">
+              <a:rPr sz="1300" b="0">
                 <a:solidFill>
                   <a:srgbClr val="000000"/>
                 </a:solidFill>
@@ -19062,7 +19062,7 @@
           <a:p>
             <a:pPr lvl="1" algn="l"/>
             <a:r>
-              <a:rPr sz="1200" b="0">
+              <a:rPr sz="1300" b="0">
                 <a:solidFill>
                   <a:srgbClr val="000000"/>
                 </a:solidFill>
@@ -19073,7 +19073,7 @@
           <a:p>
             <a:pPr lvl="1" algn="l"/>
             <a:r>
-              <a:rPr sz="1200" b="0">
+              <a:rPr sz="1300" b="0">
                 <a:solidFill>
                   <a:srgbClr val="000000"/>
                 </a:solidFill>
@@ -19084,7 +19084,7 @@
           <a:p>
             <a:pPr lvl="1" algn="l"/>
             <a:r>
-              <a:rPr sz="1200" b="0">
+              <a:rPr sz="1300" b="0">
                 <a:solidFill>
                   <a:srgbClr val="000000"/>
                 </a:solidFill>
@@ -19095,7 +19095,7 @@
           <a:p>
             <a:pPr lvl="1" algn="l"/>
             <a:r>
-              <a:rPr sz="1200" b="0">
+              <a:rPr sz="1300" b="0">
                 <a:solidFill>
                   <a:srgbClr val="000000"/>
                 </a:solidFill>
@@ -19106,7 +19106,7 @@
           <a:p>
             <a:pPr algn="l"/>
             <a:r>
-              <a:rPr sz="1100" b="1">
+              <a:rPr sz="1200" b="1">
                 <a:solidFill>
                   <a:srgbClr val="000000"/>
                 </a:solidFill>

</xml_diff>